<commit_message>
Update PPT to reflect latest features + Coze
</commit_message>
<xml_diff>
--- a/演示视频PPT.pptx
+++ b/演示视频PPT.pptx
@@ -8027,9 +8027,9 @@
                 <a:cs typeface="楷体" charset="0"/>
               </a:rPr>
               <a:t>1. 痛点：四年级动物类习作，教师无法兼顾48人个性化指导
-2. 方案：基于DeepSeek大模型，自主开发AI教育智能体
+2. 方案：基于DeepSeek V4 Pro大模型，自主开发AI教育智能体
 3. 功能：写作指导、作文批改、互动问答、范文展示
-4. 成果：学生习作字数提升32%，批改效率提升60%</a:t>
+4. 成果：学生习作字数提升32%，批改效率提升60%，并部署至扣子平台</a:t>
             </a:r>
             <a:r>
               <a:rPr lang="en-US" altLang="zh-CN" sz="2400" spc="100" dirty="0">
@@ -8999,7 +8999,7 @@
                 <a:cs typeface="楷体" charset="0"/>
                 <a:sym typeface="+mn-ea"/>
               </a:rPr>
-              <a:t>写作指导模块</a:t>
+              <a:t>写作闯关模块</a:t>
             </a:r>
             <a:r>
               <a:rPr lang="en-US" altLang="zh-CN" sz="2600" b="1" spc="100" dirty="0">
@@ -9224,7 +9224,7 @@
                 <a:cs typeface="楷体" charset="0"/>
                 <a:sym typeface="+mn-ea"/>
               </a:rPr>
-              <a:t>输入动物名称，AI生成针对性指导</a:t>
+              <a:t>五步引导式写作：选动物→外形→习性→故事→完成</a:t>
             </a:r>
             <a:r>
               <a:rPr lang="en-US" altLang="zh-CN" sz="2600" b="1" spc="100" dirty="0">
@@ -11991,7 +11991,7 @@
                 <a:cs typeface="楷体" charset="0"/>
                 <a:sym typeface="+mn-ea"/>
               </a:rPr>
-              <a:t>1. 输入动物名称，AI秒级生成针对性指导</a:t>
+              <a:t>1. 粘贴习作，AI从内容/语言/情感多维度分析</a:t>
             </a:r>
             <a:r>
               <a:rPr lang="en-US" altLang="zh-CN" sz="2000" spc="100" dirty="0">
@@ -12218,7 +12218,7 @@
                 <a:ea typeface="楷体" charset="0"/>
                 <a:cs typeface="楷体" charset="0"/>
               </a:rPr>
-              <a:t>二、互动问答与范文展示</a:t>
+              <a:t>二、互动问答与范文展示，标注年级和字数</a:t>
             </a:r>
             <a:r>
               <a:rPr lang="zh-CN" sz="3000" b="1" spc="100" dirty="0">
@@ -16533,7 +16533,7 @@
                 <a:ea typeface="楷体" charset="0"/>
                 <a:cs typeface="楷体" charset="0"/>
               </a:rPr>
-              <a:t>二、应用效果</a:t>
+              <a:t>二、创新与合规</a:t>
             </a:r>
             <a:r>
               <a:rPr lang="zh-CN" sz="3000" b="1" spc="100" dirty="0">
@@ -16869,7 +16869,7 @@
                 <a:cs typeface="楷体" charset="0"/>
                 <a:sym typeface="+mn-ea"/>
               </a:rPr>
-              <a:t>1. 学生写作兴趣从15%提升至40%，主动写作蔚然成风</a:t>
+              <a:t>1. 一生一导个性化教学 + 精准聚焦高频痛点 + 严格遵循AI使用指南</a:t>
             </a:r>
             <a:r>
               <a:rPr lang="en-US" altLang="zh-CN" sz="2000" spc="100" dirty="0">
@@ -17157,6 +17157,12 @@
               <a:latin typeface="楷体" charset="0"/>
               <a:ea typeface="楷体" charset="0"/>
             </a:endParaRPr>
+          </a:p>
+          <a:p>
+            <a:r>
+              <a:rPr sz="1200"/>
+              <a:t>GitHub: github.com/707978439-cpu/animal-writing-assistant</a:t>
+            </a:r>
           </a:p>
         </p:txBody>
       </p:sp>

</xml_diff>

<commit_message>
Add PPT images + recording guide update
</commit_message>
<xml_diff>
--- a/演示视频PPT.pptx
+++ b/演示视频PPT.pptx
@@ -8440,6 +8440,30 @@
           </p:txBody>
         </p:sp>
       </p:grpSp>
+      <p:pic>
+        <p:nvPicPr>
+          <p:cNvPr id="42" name="Picture 41" descr="modules_overview.png"/>
+          <p:cNvPicPr>
+            <a:picLocks noChangeAspect="1"/>
+          </p:cNvPicPr>
+          <p:nvPr/>
+        </p:nvPicPr>
+        <p:blipFill>
+          <a:blip r:embed="rId3"/>
+          <a:stretch>
+            <a:fillRect/>
+          </a:stretch>
+        </p:blipFill>
+        <p:spPr>
+          <a:xfrm>
+            <a:off x="400000" y="4400000"/>
+            <a:ext cx="8500000" cy="4200000"/>
+          </a:xfrm>
+          <a:prstGeom prst="rect">
+            <a:avLst/>
+          </a:prstGeom>
+        </p:spPr>
+      </p:pic>
     </p:spTree>
   </p:cSld>
   <p:clrMapOvr>
@@ -11312,6 +11336,30 @@
           </p:txBody>
         </p:sp>
       </p:grpSp>
+      <p:pic>
+        <p:nvPicPr>
+          <p:cNvPr id="72" name="Picture 71" descr="flow_5steps.png"/>
+          <p:cNvPicPr>
+            <a:picLocks noChangeAspect="1"/>
+          </p:cNvPicPr>
+          <p:nvPr/>
+        </p:nvPicPr>
+        <p:blipFill>
+          <a:blip r:embed="rId27"/>
+          <a:stretch>
+            <a:fillRect/>
+          </a:stretch>
+        </p:blipFill>
+        <p:spPr>
+          <a:xfrm>
+            <a:off x="500000" y="3800000"/>
+            <a:ext cx="9000000" cy="3600000"/>
+          </a:xfrm>
+          <a:prstGeom prst="rect">
+            <a:avLst/>
+          </a:prstGeom>
+        </p:spPr>
+      </p:pic>
     </p:spTree>
   </p:cSld>
   <p:clrMapOvr>
@@ -15616,6 +15664,30 @@
           </p:txBody>
         </p:sp>
       </p:grpSp>
+      <p:pic>
+        <p:nvPicPr>
+          <p:cNvPr id="72" name="Picture 71" descr="data_chart.png"/>
+          <p:cNvPicPr>
+            <a:picLocks noChangeAspect="1"/>
+          </p:cNvPicPr>
+          <p:nvPr/>
+        </p:nvPicPr>
+        <p:blipFill>
+          <a:blip r:embed="rId27"/>
+          <a:stretch>
+            <a:fillRect/>
+          </a:stretch>
+        </p:blipFill>
+        <p:spPr>
+          <a:xfrm>
+            <a:off x="500000" y="4200000"/>
+            <a:ext cx="8500000" cy="3500000"/>
+          </a:xfrm>
+          <a:prstGeom prst="rect">
+            <a:avLst/>
+          </a:prstGeom>
+        </p:spPr>
+      </p:pic>
     </p:spTree>
   </p:cSld>
   <p:clrMapOvr>

</xml_diff>

<commit_message>
Replace PPT images with real app screenshots
</commit_message>
<xml_diff>
--- a/演示视频PPT.pptx
+++ b/演示视频PPT.pptx
@@ -11360,6 +11360,30 @@
           </a:prstGeom>
         </p:spPr>
       </p:pic>
+      <p:pic>
+        <p:nvPicPr>
+          <p:cNvPr id="73" name="Picture 72" descr="slide3_challenge.png"/>
+          <p:cNvPicPr>
+            <a:picLocks noChangeAspect="1"/>
+          </p:cNvPicPr>
+          <p:nvPr/>
+        </p:nvPicPr>
+        <p:blipFill>
+          <a:blip r:embed="rId28"/>
+          <a:stretch>
+            <a:fillRect/>
+          </a:stretch>
+        </p:blipFill>
+        <p:spPr>
+          <a:xfrm>
+            <a:off x="500000" y="3800000"/>
+            <a:ext cx="9000000" cy="3600000"/>
+          </a:xfrm>
+          <a:prstGeom prst="rect">
+            <a:avLst/>
+          </a:prstGeom>
+        </p:spPr>
+      </p:pic>
     </p:spTree>
   </p:cSld>
   <p:clrMapOvr>
@@ -12076,6 +12100,30 @@
           </a:p>
         </p:txBody>
       </p:sp>
+      <p:pic>
+        <p:nvPicPr>
+          <p:cNvPr id="27" name="Picture 26" descr="slide4_wordwall.png"/>
+          <p:cNvPicPr>
+            <a:picLocks noChangeAspect="1"/>
+          </p:cNvPicPr>
+          <p:nvPr/>
+        </p:nvPicPr>
+        <p:blipFill>
+          <a:blip r:embed="rId3"/>
+          <a:stretch>
+            <a:fillRect/>
+          </a:stretch>
+        </p:blipFill>
+        <p:spPr>
+          <a:xfrm>
+            <a:off x="500000" y="4200000"/>
+            <a:ext cx="8500000" cy="3500000"/>
+          </a:xfrm>
+          <a:prstGeom prst="rect">
+            <a:avLst/>
+          </a:prstGeom>
+        </p:spPr>
+      </p:pic>
     </p:spTree>
   </p:cSld>
   <p:clrMapOvr>
@@ -12792,6 +12840,30 @@
           </a:p>
         </p:txBody>
       </p:sp>
+      <p:pic>
+        <p:nvPicPr>
+          <p:cNvPr id="26" name="Picture 25" descr="slide5_review.png"/>
+          <p:cNvPicPr>
+            <a:picLocks noChangeAspect="1"/>
+          </p:cNvPicPr>
+          <p:nvPr/>
+        </p:nvPicPr>
+        <p:blipFill>
+          <a:blip r:embed="rId3"/>
+          <a:stretch>
+            <a:fillRect/>
+          </a:stretch>
+        </p:blipFill>
+        <p:spPr>
+          <a:xfrm>
+            <a:off x="500000" y="4200000"/>
+            <a:ext cx="8500000" cy="3500000"/>
+          </a:xfrm>
+          <a:prstGeom prst="rect">
+            <a:avLst/>
+          </a:prstGeom>
+        </p:spPr>
+      </p:pic>
     </p:spTree>
   </p:cSld>
   <p:clrMapOvr>
@@ -15674,6 +15746,30 @@
         </p:nvPicPr>
         <p:blipFill>
           <a:blip r:embed="rId27"/>
+          <a:stretch>
+            <a:fillRect/>
+          </a:stretch>
+        </p:blipFill>
+        <p:spPr>
+          <a:xfrm>
+            <a:off x="500000" y="4200000"/>
+            <a:ext cx="8500000" cy="3500000"/>
+          </a:xfrm>
+          <a:prstGeom prst="rect">
+            <a:avLst/>
+          </a:prstGeom>
+        </p:spPr>
+      </p:pic>
+      <p:pic>
+        <p:nvPicPr>
+          <p:cNvPr id="73" name="Picture 72" descr="slide6_samples.png"/>
+          <p:cNvPicPr>
+            <a:picLocks noChangeAspect="1"/>
+          </p:cNvPicPr>
+          <p:nvPr/>
+        </p:nvPicPr>
+        <p:blipFill>
+          <a:blip r:embed="rId28"/>
           <a:stretch>
             <a:fillRect/>
           </a:stretch>

</xml_diff>

<commit_message>
Add multi-device compatibility info to all docs
</commit_message>
<xml_diff>
--- a/演示视频PPT.pptx
+++ b/演示视频PPT.pptx
@@ -122,7 +122,7 @@
   <p:extLst>
     <p:ext uri="{EFAFB233-063F-42B5-8137-9DF3F51BA10A}">
       <p15:sldGuideLst xmlns:p15="http://schemas.microsoft.com/office/powerpoint/2012/main">
-        <p15:guide id="1" orient="horz" pos="2236" userDrawn="1">
+        <p15:guide id="1" orient="horz" pos="2237" userDrawn="1">
           <p15:clr>
             <a:srgbClr val="A4A3A4"/>
           </p15:clr>
@@ -5563,7 +5563,7 @@
         <a:spcBef>
           <a:spcPts val="1000"/>
         </a:spcBef>
-        <a:buFont typeface="Arial" panose="02080604020202020204" pitchFamily="34" charset="0"/>
+        <a:buFont typeface="Arial" panose="020B0604020202090204" pitchFamily="34" charset="0"/>
         <a:buChar char="•"/>
         <a:defRPr sz="2800" kern="1200">
           <a:solidFill>
@@ -5581,7 +5581,7 @@
         <a:spcBef>
           <a:spcPts val="500"/>
         </a:spcBef>
-        <a:buFont typeface="Arial" panose="02080604020202020204" pitchFamily="34" charset="0"/>
+        <a:buFont typeface="Arial" panose="020B0604020202090204" pitchFamily="34" charset="0"/>
         <a:buChar char="•"/>
         <a:defRPr sz="2400" kern="1200">
           <a:solidFill>
@@ -5599,7 +5599,7 @@
         <a:spcBef>
           <a:spcPts val="500"/>
         </a:spcBef>
-        <a:buFont typeface="Arial" panose="02080604020202020204" pitchFamily="34" charset="0"/>
+        <a:buFont typeface="Arial" panose="020B0604020202090204" pitchFamily="34" charset="0"/>
         <a:buChar char="•"/>
         <a:defRPr sz="2000" kern="1200">
           <a:solidFill>
@@ -5617,7 +5617,7 @@
         <a:spcBef>
           <a:spcPts val="500"/>
         </a:spcBef>
-        <a:buFont typeface="Arial" panose="02080604020202020204" pitchFamily="34" charset="0"/>
+        <a:buFont typeface="Arial" panose="020B0604020202090204" pitchFamily="34" charset="0"/>
         <a:buChar char="•"/>
         <a:defRPr sz="1800" kern="1200">
           <a:solidFill>
@@ -5635,7 +5635,7 @@
         <a:spcBef>
           <a:spcPts val="500"/>
         </a:spcBef>
-        <a:buFont typeface="Arial" panose="02080604020202020204" pitchFamily="34" charset="0"/>
+        <a:buFont typeface="Arial" panose="020B0604020202090204" pitchFamily="34" charset="0"/>
         <a:buChar char="•"/>
         <a:defRPr sz="1800" kern="1200">
           <a:solidFill>
@@ -5653,7 +5653,7 @@
         <a:spcBef>
           <a:spcPts val="500"/>
         </a:spcBef>
-        <a:buFont typeface="Arial" panose="02080604020202020204" pitchFamily="34" charset="0"/>
+        <a:buFont typeface="Arial" panose="020B0604020202090204" pitchFamily="34" charset="0"/>
         <a:buChar char="•"/>
         <a:defRPr sz="1800" kern="1200">
           <a:solidFill>
@@ -5671,7 +5671,7 @@
         <a:spcBef>
           <a:spcPts val="500"/>
         </a:spcBef>
-        <a:buFont typeface="Arial" panose="02080604020202020204" pitchFamily="34" charset="0"/>
+        <a:buFont typeface="Arial" panose="020B0604020202090204" pitchFamily="34" charset="0"/>
         <a:buChar char="•"/>
         <a:defRPr sz="1800" kern="1200">
           <a:solidFill>
@@ -5689,7 +5689,7 @@
         <a:spcBef>
           <a:spcPts val="500"/>
         </a:spcBef>
-        <a:buFont typeface="Arial" panose="02080604020202020204" pitchFamily="34" charset="0"/>
+        <a:buFont typeface="Arial" panose="020B0604020202090204" pitchFamily="34" charset="0"/>
         <a:buChar char="•"/>
         <a:defRPr sz="1800" kern="1200">
           <a:solidFill>
@@ -5707,7 +5707,7 @@
         <a:spcBef>
           <a:spcPts val="500"/>
         </a:spcBef>
-        <a:buFont typeface="Arial" panose="02080604020202020204" pitchFamily="34" charset="0"/>
+        <a:buFont typeface="Arial" panose="020B0604020202090204" pitchFamily="34" charset="0"/>
         <a:buChar char="•"/>
         <a:defRPr sz="1800" kern="1200">
           <a:solidFill>
@@ -6112,7 +6112,7 @@
         <a:spcBef>
           <a:spcPts val="1000"/>
         </a:spcBef>
-        <a:buFont typeface="Arial" panose="02080604020202020204" pitchFamily="34" charset="0"/>
+        <a:buFont typeface="Arial" panose="020B0604020202090204" pitchFamily="34" charset="0"/>
         <a:buChar char="•"/>
         <a:defRPr sz="2800" kern="1200">
           <a:solidFill>
@@ -6130,7 +6130,7 @@
         <a:spcBef>
           <a:spcPts val="500"/>
         </a:spcBef>
-        <a:buFont typeface="Arial" panose="02080604020202020204" pitchFamily="34" charset="0"/>
+        <a:buFont typeface="Arial" panose="020B0604020202090204" pitchFamily="34" charset="0"/>
         <a:buChar char="•"/>
         <a:defRPr sz="2400" kern="1200">
           <a:solidFill>
@@ -6148,7 +6148,7 @@
         <a:spcBef>
           <a:spcPts val="500"/>
         </a:spcBef>
-        <a:buFont typeface="Arial" panose="02080604020202020204" pitchFamily="34" charset="0"/>
+        <a:buFont typeface="Arial" panose="020B0604020202090204" pitchFamily="34" charset="0"/>
         <a:buChar char="•"/>
         <a:defRPr sz="2000" kern="1200">
           <a:solidFill>
@@ -6166,7 +6166,7 @@
         <a:spcBef>
           <a:spcPts val="500"/>
         </a:spcBef>
-        <a:buFont typeface="Arial" panose="02080604020202020204" pitchFamily="34" charset="0"/>
+        <a:buFont typeface="Arial" panose="020B0604020202090204" pitchFamily="34" charset="0"/>
         <a:buChar char="•"/>
         <a:defRPr sz="1800" kern="1200">
           <a:solidFill>
@@ -6184,7 +6184,7 @@
         <a:spcBef>
           <a:spcPts val="500"/>
         </a:spcBef>
-        <a:buFont typeface="Arial" panose="02080604020202020204" pitchFamily="34" charset="0"/>
+        <a:buFont typeface="Arial" panose="020B0604020202090204" pitchFamily="34" charset="0"/>
         <a:buChar char="•"/>
         <a:defRPr sz="1800" kern="1200">
           <a:solidFill>
@@ -6202,7 +6202,7 @@
         <a:spcBef>
           <a:spcPts val="500"/>
         </a:spcBef>
-        <a:buFont typeface="Arial" panose="02080604020202020204" pitchFamily="34" charset="0"/>
+        <a:buFont typeface="Arial" panose="020B0604020202090204" pitchFamily="34" charset="0"/>
         <a:buChar char="•"/>
         <a:defRPr sz="1800" kern="1200">
           <a:solidFill>
@@ -6220,7 +6220,7 @@
         <a:spcBef>
           <a:spcPts val="500"/>
         </a:spcBef>
-        <a:buFont typeface="Arial" panose="02080604020202020204" pitchFamily="34" charset="0"/>
+        <a:buFont typeface="Arial" panose="020B0604020202090204" pitchFamily="34" charset="0"/>
         <a:buChar char="•"/>
         <a:defRPr sz="1800" kern="1200">
           <a:solidFill>
@@ -6238,7 +6238,7 @@
         <a:spcBef>
           <a:spcPts val="500"/>
         </a:spcBef>
-        <a:buFont typeface="Arial" panose="02080604020202020204" pitchFamily="34" charset="0"/>
+        <a:buFont typeface="Arial" panose="020B0604020202090204" pitchFamily="34" charset="0"/>
         <a:buChar char="•"/>
         <a:defRPr sz="1800" kern="1200">
           <a:solidFill>
@@ -6256,7 +6256,7 @@
         <a:spcBef>
           <a:spcPts val="500"/>
         </a:spcBef>
-        <a:buFont typeface="Arial" panose="02080604020202020204" pitchFamily="34" charset="0"/>
+        <a:buFont typeface="Arial" panose="020B0604020202090204" pitchFamily="34" charset="0"/>
         <a:buChar char="•"/>
         <a:defRPr sz="1800" kern="1200">
           <a:solidFill>
@@ -6846,50 +6846,6 @@
               </a:rPr>
               <a:t>动物习作AI智能助教</a:t>
             </a:r>
-            <a:r>
-              <a:rPr lang="en-US" altLang="zh-CN" sz="4000" b="1" spc="100" dirty="0">
-                <a:solidFill>
-                  <a:schemeClr val="bg1"/>
-                </a:solidFill>
-                <a:latin typeface="楷体" charset="0"/>
-                <a:ea typeface="楷体" charset="0"/>
-                <a:cs typeface="楷体" charset="0"/>
-              </a:rPr>
-              <a:t/>
-            </a:r>
-            <a:r>
-              <a:rPr lang="zh-CN" altLang="en-US" sz="4000" b="1" spc="100" dirty="0">
-                <a:solidFill>
-                  <a:schemeClr val="bg1"/>
-                </a:solidFill>
-                <a:latin typeface="楷体" charset="0"/>
-                <a:ea typeface="楷体" charset="0"/>
-                <a:cs typeface="楷体" charset="0"/>
-              </a:rPr>
-              <a:t/>
-            </a:r>
-            <a:r>
-              <a:rPr lang="en-US" altLang="zh-CN" sz="4000" b="1" spc="100" dirty="0">
-                <a:solidFill>
-                  <a:schemeClr val="bg1"/>
-                </a:solidFill>
-                <a:latin typeface="楷体" charset="0"/>
-                <a:ea typeface="楷体" charset="0"/>
-                <a:cs typeface="楷体" charset="0"/>
-              </a:rPr>
-              <a:t/>
-            </a:r>
-            <a:r>
-              <a:rPr lang="zh-CN" altLang="en-US" sz="4000" b="1" spc="100" dirty="0">
-                <a:solidFill>
-                  <a:schemeClr val="bg1"/>
-                </a:solidFill>
-                <a:latin typeface="楷体" charset="0"/>
-                <a:ea typeface="楷体" charset="0"/>
-                <a:cs typeface="楷体" charset="0"/>
-              </a:rPr>
-              <a:t/>
-            </a:r>
             <a:endParaRPr lang="zh-CN" altLang="en-US" sz="4000" b="1" spc="100" dirty="0">
               <a:solidFill>
                 <a:schemeClr val="bg1"/>
@@ -7046,54 +7002,6 @@
               </a:rPr>
               <a:t>惠州市富民小学</a:t>
             </a:r>
-            <a:r>
-              <a:rPr lang="en-US" altLang="zh-CN" sz="2400" b="1" spc="100" dirty="0">
-                <a:solidFill>
-                  <a:schemeClr val="bg1"/>
-                </a:solidFill>
-                <a:latin typeface="楷体" charset="0"/>
-                <a:ea typeface="楷体" charset="0"/>
-                <a:cs typeface="楷体" charset="0"/>
-                <a:sym typeface="+mn-ea"/>
-              </a:rPr>
-              <a:t/>
-            </a:r>
-            <a:r>
-              <a:rPr lang="zh-CN" altLang="en-US" sz="2400" b="1" spc="100" dirty="0">
-                <a:solidFill>
-                  <a:schemeClr val="bg1"/>
-                </a:solidFill>
-                <a:latin typeface="楷体" charset="0"/>
-                <a:ea typeface="楷体" charset="0"/>
-                <a:cs typeface="楷体" charset="0"/>
-                <a:sym typeface="+mn-ea"/>
-              </a:rPr>
-              <a:t/>
-            </a:r>
-            <a:r>
-              <a:rPr lang="en-US" altLang="zh-CN" sz="2400" b="1" spc="100" dirty="0">
-                <a:solidFill>
-                  <a:schemeClr val="bg1"/>
-                </a:solidFill>
-                <a:latin typeface="楷体" charset="0"/>
-                <a:ea typeface="楷体" charset="0"/>
-                <a:cs typeface="楷体" charset="0"/>
-                <a:sym typeface="+mn-ea"/>
-              </a:rPr>
-              <a:t/>
-            </a:r>
-            <a:r>
-              <a:rPr lang="zh-CN" altLang="en-US" sz="2400" b="1" spc="100" dirty="0">
-                <a:solidFill>
-                  <a:schemeClr val="bg1"/>
-                </a:solidFill>
-                <a:latin typeface="楷体" charset="0"/>
-                <a:ea typeface="楷体" charset="0"/>
-                <a:cs typeface="楷体" charset="0"/>
-                <a:sym typeface="+mn-ea"/>
-              </a:rPr>
-              <a:t/>
-            </a:r>
             <a:endParaRPr lang="zh-CN" altLang="en-US" sz="2400" b="1" spc="100" dirty="0">
               <a:solidFill>
                 <a:schemeClr val="bg1"/>
@@ -7263,94 +7171,6 @@
                 <a:cs typeface="楷体" charset="0"/>
               </a:rPr>
               <a:t>许志超</a:t>
-            </a:r>
-            <a:r>
-              <a:rPr lang="zh-CN" altLang="en-US" sz="2400" b="1" spc="100" dirty="0">
-                <a:solidFill>
-                  <a:schemeClr val="bg1"/>
-                </a:solidFill>
-                <a:latin typeface="楷体" charset="0"/>
-                <a:ea typeface="楷体" charset="0"/>
-                <a:cs typeface="楷体" charset="0"/>
-              </a:rPr>
-              <a:t/>
-            </a:r>
-            <a:r>
-              <a:rPr lang="en-US" altLang="zh-CN" sz="2400" b="1" spc="100" dirty="0">
-                <a:solidFill>
-                  <a:schemeClr val="bg1"/>
-                </a:solidFill>
-                <a:latin typeface="楷体" charset="0"/>
-                <a:ea typeface="楷体" charset="0"/>
-                <a:cs typeface="楷体" charset="0"/>
-              </a:rPr>
-              <a:t/>
-            </a:r>
-            <a:r>
-              <a:rPr lang="zh-CN" altLang="en-US" sz="2400" b="1" spc="100" dirty="0">
-                <a:solidFill>
-                  <a:schemeClr val="bg1"/>
-                </a:solidFill>
-                <a:latin typeface="楷体" charset="0"/>
-                <a:ea typeface="楷体" charset="0"/>
-                <a:cs typeface="楷体" charset="0"/>
-              </a:rPr>
-              <a:t/>
-            </a:r>
-            <a:r>
-              <a:rPr lang="en-US" altLang="zh-CN" sz="2400" b="1" spc="100" dirty="0">
-                <a:solidFill>
-                  <a:schemeClr val="bg1"/>
-                </a:solidFill>
-                <a:latin typeface="楷体" charset="0"/>
-                <a:ea typeface="楷体" charset="0"/>
-                <a:cs typeface="楷体" charset="0"/>
-              </a:rPr>
-              <a:t/>
-            </a:r>
-            <a:r>
-              <a:rPr lang="zh-CN" altLang="en-US" sz="2400" b="1" spc="100" dirty="0">
-                <a:solidFill>
-                  <a:schemeClr val="bg1"/>
-                </a:solidFill>
-                <a:latin typeface="楷体" charset="0"/>
-                <a:ea typeface="楷体" charset="0"/>
-                <a:cs typeface="楷体" charset="0"/>
-              </a:rPr>
-              <a:t/>
-            </a:r>
-            <a:r>
-              <a:rPr lang="en-US" altLang="zh-CN" sz="2400" b="1" spc="100" dirty="0">
-                <a:solidFill>
-                  <a:schemeClr val="bg1"/>
-                </a:solidFill>
-                <a:latin typeface="楷体" charset="0"/>
-                <a:ea typeface="楷体" charset="0"/>
-                <a:cs typeface="楷体" charset="0"/>
-              </a:rPr>
-              <a:t/>
-            </a:r>
-            <a:r>
-              <a:rPr lang="zh-CN" altLang="en-US" sz="2400" b="1" spc="100" dirty="0">
-                <a:solidFill>
-                  <a:schemeClr val="bg1"/>
-                </a:solidFill>
-                <a:latin typeface="楷体" charset="0"/>
-                <a:ea typeface="楷体" charset="0"/>
-                <a:cs typeface="楷体" charset="0"/>
-              </a:rPr>
-              <a:t/>
-            </a:r>
-            <a:r>
-              <a:rPr lang="en-US" altLang="zh-CN" sz="2400" b="1" spc="100" dirty="0">
-                <a:solidFill>
-                  <a:schemeClr val="bg1"/>
-                </a:solidFill>
-                <a:latin typeface="楷体" charset="0"/>
-                <a:ea typeface="楷体" charset="0"/>
-                <a:cs typeface="楷体" charset="0"/>
-              </a:rPr>
-              <a:t/>
             </a:r>
             <a:endParaRPr lang="en-US" altLang="zh-CN" sz="2400" b="1" spc="100" dirty="0">
               <a:solidFill>
@@ -8029,7 +7849,7 @@
               <a:t>1. 痛点：四年级动物类习作，教师无法兼顾48人个性化指导
 2. 方案：基于DeepSeek V4 Pro大模型，自主开发AI教育智能体
 3. 功能：写作指导、作文批改、互动问答、范文展示
-4. 成果：学生习作字数提升32%，批改效率提升60%，并部署至扣子平台</a:t>
+4. 成果：学生习作字数提升32%，批改效率提升60%，并部署至</a:t>
             </a:r>
             <a:r>
               <a:rPr lang="en-US" altLang="zh-CN" sz="2400" spc="100" dirty="0">
@@ -8040,7 +7860,7 @@
                 <a:ea typeface="楷体" charset="0"/>
                 <a:cs typeface="楷体" charset="0"/>
               </a:rPr>
-              <a:t/>
+              <a:t>github</a:t>
             </a:r>
             <a:r>
               <a:rPr lang="zh-CN" altLang="en-US" sz="2400" spc="100" dirty="0">
@@ -8051,7 +7871,29 @@
                 <a:ea typeface="楷体" charset="0"/>
                 <a:cs typeface="楷体" charset="0"/>
               </a:rPr>
-              <a:t/>
+              <a:t>代码共享平台</a:t>
+            </a:r>
+            <a:r>
+              <a:rPr lang="zh-CN" altLang="en-US" sz="2400" spc="100" dirty="0">
+                <a:solidFill>
+                  <a:schemeClr val="tx1"/>
+                </a:solidFill>
+                <a:latin typeface="楷体" charset="0"/>
+                <a:ea typeface="楷体" charset="0"/>
+                <a:cs typeface="楷体" charset="0"/>
+              </a:rPr>
+              <a:t>以及国内广泛应用</a:t>
+            </a:r>
+            <a:r>
+              <a:rPr lang="zh-CN" altLang="en-US" sz="2400" spc="100" dirty="0">
+                <a:solidFill>
+                  <a:schemeClr val="tx1"/>
+                </a:solidFill>
+                <a:latin typeface="楷体" charset="0"/>
+                <a:ea typeface="楷体" charset="0"/>
+                <a:cs typeface="楷体" charset="0"/>
+              </a:rPr>
+              <a:t>的扣子平台 | 兼容电脑/手机/希沃白板，多设备同时访问</a:t>
             </a:r>
             <a:endParaRPr lang="zh-CN" altLang="en-US" sz="2400" spc="100" dirty="0">
               <a:solidFill>
@@ -8440,30 +8282,6 @@
           </p:txBody>
         </p:sp>
       </p:grpSp>
-      <p:pic>
-        <p:nvPicPr>
-          <p:cNvPr id="42" name="Picture 41" descr="modules_overview.png"/>
-          <p:cNvPicPr>
-            <a:picLocks noChangeAspect="1"/>
-          </p:cNvPicPr>
-          <p:nvPr/>
-        </p:nvPicPr>
-        <p:blipFill>
-          <a:blip r:embed="rId3"/>
-          <a:stretch>
-            <a:fillRect/>
-          </a:stretch>
-        </p:blipFill>
-        <p:spPr>
-          <a:xfrm>
-            <a:off x="400000" y="4400000"/>
-            <a:ext cx="8500000" cy="4200000"/>
-          </a:xfrm>
-          <a:prstGeom prst="rect">
-            <a:avLst/>
-          </a:prstGeom>
-        </p:spPr>
-      </p:pic>
     </p:spTree>
   </p:cSld>
   <p:clrMapOvr>
@@ -9025,66 +8843,6 @@
               </a:rPr>
               <a:t>写作闯关模块</a:t>
             </a:r>
-            <a:r>
-              <a:rPr lang="en-US" altLang="zh-CN" sz="2600" b="1" spc="100" dirty="0">
-                <a:solidFill>
-                  <a:srgbClr val="0070C0"/>
-                </a:solidFill>
-                <a:latin typeface="楷体" charset="0"/>
-                <a:ea typeface="楷体" charset="0"/>
-                <a:cs typeface="楷体" charset="0"/>
-                <a:sym typeface="+mn-ea"/>
-              </a:rPr>
-              <a:t/>
-            </a:r>
-            <a:r>
-              <a:rPr lang="zh-CN" altLang="en-US" sz="2600" b="1" spc="100" dirty="0">
-                <a:solidFill>
-                  <a:srgbClr val="0070C0"/>
-                </a:solidFill>
-                <a:latin typeface="楷体" charset="0"/>
-                <a:ea typeface="楷体" charset="0"/>
-                <a:cs typeface="楷体" charset="0"/>
-                <a:sym typeface="+mn-ea"/>
-              </a:rPr>
-              <a:t/>
-            </a:r>
-            <a:r>
-              <a:rPr lang="en-US" altLang="zh-CN" sz="2600" b="1" spc="100" dirty="0">
-                <a:solidFill>
-                  <a:srgbClr val="0070C0"/>
-                </a:solidFill>
-                <a:latin typeface="楷体" charset="0"/>
-                <a:ea typeface="楷体" charset="0"/>
-                <a:cs typeface="楷体" charset="0"/>
-                <a:sym typeface="+mn-ea"/>
-              </a:rPr>
-              <a:t/>
-            </a:r>
-            <a:r>
-              <a:rPr lang="zh-CN" altLang="en-US" sz="2600" b="1" spc="100" dirty="0">
-                <a:solidFill>
-                  <a:srgbClr val="0070C0"/>
-                </a:solidFill>
-                <a:latin typeface="楷体" charset="0"/>
-                <a:ea typeface="楷体" charset="0"/>
-                <a:cs typeface="楷体" charset="0"/>
-                <a:sym typeface="+mn-ea"/>
-              </a:rPr>
-              <a:t/>
-            </a:r>
-            <a:r>
-              <a:rPr lang="en-US" altLang="zh-CN" sz="2600" b="1" spc="100" dirty="0">
-                <a:solidFill>
-                  <a:srgbClr val="0070C0"/>
-                </a:solidFill>
-                <a:latin typeface="楷体" charset="0"/>
-                <a:ea typeface="楷体" charset="0"/>
-                <a:cs typeface="楷体" charset="0"/>
-                <a:sym typeface="+mn-ea"/>
-              </a:rPr>
-              <a:t/>
-            </a:r>
             <a:endParaRPr lang="en-US" altLang="zh-CN" sz="2600" b="1" spc="100" dirty="0">
               <a:solidFill>
                 <a:srgbClr val="0070C0"/>
@@ -9250,54 +9008,6 @@
               </a:rPr>
               <a:t>五步引导式写作：选动物→外形→习性→故事→完成</a:t>
             </a:r>
-            <a:r>
-              <a:rPr lang="en-US" altLang="zh-CN" sz="2600" b="1" spc="100" dirty="0">
-                <a:solidFill>
-                  <a:srgbClr val="0070C0"/>
-                </a:solidFill>
-                <a:latin typeface="楷体" charset="0"/>
-                <a:ea typeface="楷体" charset="0"/>
-                <a:cs typeface="楷体" charset="0"/>
-                <a:sym typeface="+mn-ea"/>
-              </a:rPr>
-              <a:t/>
-            </a:r>
-            <a:r>
-              <a:rPr lang="zh-CN" altLang="en-US" sz="2600" b="1" spc="100" dirty="0">
-                <a:solidFill>
-                  <a:srgbClr val="0070C0"/>
-                </a:solidFill>
-                <a:latin typeface="楷体" charset="0"/>
-                <a:ea typeface="楷体" charset="0"/>
-                <a:cs typeface="楷体" charset="0"/>
-                <a:sym typeface="+mn-ea"/>
-              </a:rPr>
-              <a:t/>
-            </a:r>
-            <a:r>
-              <a:rPr lang="zh-CN" sz="2600" b="1" spc="100" dirty="0">
-                <a:solidFill>
-                  <a:srgbClr val="0070C0"/>
-                </a:solidFill>
-                <a:latin typeface="楷体" charset="0"/>
-                <a:ea typeface="楷体" charset="0"/>
-                <a:cs typeface="楷体" charset="0"/>
-                <a:sym typeface="+mn-ea"/>
-              </a:rPr>
-              <a:t/>
-            </a:r>
-            <a:r>
-              <a:rPr lang="en-US" altLang="zh-CN" sz="2600" b="1" spc="100" dirty="0">
-                <a:solidFill>
-                  <a:srgbClr val="0070C0"/>
-                </a:solidFill>
-                <a:latin typeface="楷体" charset="0"/>
-                <a:ea typeface="楷体" charset="0"/>
-                <a:cs typeface="楷体" charset="0"/>
-                <a:sym typeface="+mn-ea"/>
-              </a:rPr>
-              <a:t/>
-            </a:r>
             <a:endParaRPr lang="en-US" altLang="zh-CN" sz="2600" b="1" spc="100" dirty="0">
               <a:solidFill>
                 <a:srgbClr val="0070C0"/>
@@ -9673,18 +9383,6 @@
               <a:buSzTx/>
               <a:buFontTx/>
             </a:pPr>
-            <a:r>
-              <a:rPr lang="zh-CN" altLang="en-US" sz="2600" b="1" spc="100" dirty="0">
-                <a:solidFill>
-                  <a:srgbClr val="0070C0"/>
-                </a:solidFill>
-                <a:latin typeface="楷体" charset="0"/>
-                <a:ea typeface="楷体" charset="0"/>
-                <a:cs typeface="楷体" charset="0"/>
-                <a:sym typeface="+mn-ea"/>
-              </a:rPr>
-              <a:t/>
-            </a:r>
             <a:endParaRPr lang="zh-CN" altLang="en-US" sz="2600" b="1" spc="100" dirty="0">
               <a:solidFill>
                 <a:srgbClr val="0070C0"/>
@@ -11336,54 +11034,6 @@
           </p:txBody>
         </p:sp>
       </p:grpSp>
-      <p:pic>
-        <p:nvPicPr>
-          <p:cNvPr id="72" name="Picture 71" descr="flow_5steps.png"/>
-          <p:cNvPicPr>
-            <a:picLocks noChangeAspect="1"/>
-          </p:cNvPicPr>
-          <p:nvPr/>
-        </p:nvPicPr>
-        <p:blipFill>
-          <a:blip r:embed="rId27"/>
-          <a:stretch>
-            <a:fillRect/>
-          </a:stretch>
-        </p:blipFill>
-        <p:spPr>
-          <a:xfrm>
-            <a:off x="500000" y="3800000"/>
-            <a:ext cx="9000000" cy="3600000"/>
-          </a:xfrm>
-          <a:prstGeom prst="rect">
-            <a:avLst/>
-          </a:prstGeom>
-        </p:spPr>
-      </p:pic>
-      <p:pic>
-        <p:nvPicPr>
-          <p:cNvPr id="73" name="Picture 72" descr="slide3_challenge.png"/>
-          <p:cNvPicPr>
-            <a:picLocks noChangeAspect="1"/>
-          </p:cNvPicPr>
-          <p:nvPr/>
-        </p:nvPicPr>
-        <p:blipFill>
-          <a:blip r:embed="rId28"/>
-          <a:stretch>
-            <a:fillRect/>
-          </a:stretch>
-        </p:blipFill>
-        <p:spPr>
-          <a:xfrm>
-            <a:off x="500000" y="3800000"/>
-            <a:ext cx="9000000" cy="3600000"/>
-          </a:xfrm>
-          <a:prstGeom prst="rect">
-            <a:avLst/>
-          </a:prstGeom>
-        </p:spPr>
-      </p:pic>
     </p:spTree>
   </p:cSld>
   <p:clrMapOvr>
@@ -11576,39 +11226,6 @@
               </a:rPr>
               <a:t>一、写作指导</a:t>
             </a:r>
-            <a:r>
-              <a:rPr lang="zh-CN" sz="3000" b="1" spc="100" dirty="0">
-                <a:solidFill>
-                  <a:schemeClr val="bg1"/>
-                </a:solidFill>
-                <a:latin typeface="楷体" charset="0"/>
-                <a:ea typeface="楷体" charset="0"/>
-                <a:cs typeface="楷体" charset="0"/>
-              </a:rPr>
-              <a:t/>
-            </a:r>
-            <a:r>
-              <a:rPr lang="en-US" altLang="zh-CN" sz="3000" b="1" spc="100" dirty="0">
-                <a:solidFill>
-                  <a:schemeClr val="bg1"/>
-                </a:solidFill>
-                <a:latin typeface="楷体" charset="0"/>
-                <a:ea typeface="楷体" charset="0"/>
-                <a:cs typeface="楷体" charset="0"/>
-              </a:rPr>
-              <a:t/>
-            </a:r>
-            <a:r>
-              <a:rPr lang="zh-CN" altLang="en-US" sz="3000" b="1" spc="100" dirty="0">
-                <a:solidFill>
-                  <a:schemeClr val="bg1"/>
-                </a:solidFill>
-                <a:latin typeface="楷体" charset="0"/>
-                <a:ea typeface="楷体" charset="0"/>
-                <a:cs typeface="楷体" charset="0"/>
-              </a:rPr>
-              <a:t/>
-            </a:r>
             <a:endParaRPr lang="zh-CN" altLang="en-US" sz="3000" b="1" spc="100" dirty="0">
               <a:solidFill>
                 <a:schemeClr val="bg1"/>
@@ -12065,30 +11682,6 @@
               </a:rPr>
               <a:t>1. 粘贴习作，AI从内容/语言/情感多维度分析</a:t>
             </a:r>
-            <a:r>
-              <a:rPr lang="en-US" altLang="zh-CN" sz="2000" spc="100" dirty="0">
-                <a:solidFill>
-                  <a:schemeClr val="tx1"/>
-                </a:solidFill>
-                <a:latin typeface="楷体" charset="0"/>
-                <a:ea typeface="楷体" charset="0"/>
-                <a:cs typeface="楷体" charset="0"/>
-                <a:sym typeface="+mn-ea"/>
-              </a:rPr>
-              <a:t/>
-            </a:r>
-            <a:r>
-              <a:rPr lang="zh-CN" altLang="en-US" sz="2000" spc="100" dirty="0">
-                <a:solidFill>
-                  <a:schemeClr val="tx1"/>
-                </a:solidFill>
-                <a:latin typeface="楷体" charset="0"/>
-                <a:ea typeface="楷体" charset="0"/>
-                <a:cs typeface="楷体" charset="0"/>
-                <a:sym typeface="+mn-ea"/>
-              </a:rPr>
-              <a:t/>
-            </a:r>
             <a:endParaRPr lang="zh-CN" altLang="en-US" sz="2000" spc="100" dirty="0">
               <a:solidFill>
                 <a:schemeClr val="tx1"/>
@@ -12100,30 +11693,6 @@
           </a:p>
         </p:txBody>
       </p:sp>
-      <p:pic>
-        <p:nvPicPr>
-          <p:cNvPr id="27" name="Picture 26" descr="slide4_wordwall.png"/>
-          <p:cNvPicPr>
-            <a:picLocks noChangeAspect="1"/>
-          </p:cNvPicPr>
-          <p:nvPr/>
-        </p:nvPicPr>
-        <p:blipFill>
-          <a:blip r:embed="rId3"/>
-          <a:stretch>
-            <a:fillRect/>
-          </a:stretch>
-        </p:blipFill>
-        <p:spPr>
-          <a:xfrm>
-            <a:off x="500000" y="4200000"/>
-            <a:ext cx="8500000" cy="3500000"/>
-          </a:xfrm>
-          <a:prstGeom prst="rect">
-            <a:avLst/>
-          </a:prstGeom>
-        </p:spPr>
-      </p:pic>
     </p:spTree>
   </p:cSld>
   <p:clrMapOvr>
@@ -12316,39 +11885,6 @@
               </a:rPr>
               <a:t>二、互动问答与范文展示，标注年级和字数</a:t>
             </a:r>
-            <a:r>
-              <a:rPr lang="zh-CN" sz="3000" b="1" spc="100" dirty="0">
-                <a:solidFill>
-                  <a:schemeClr val="bg1"/>
-                </a:solidFill>
-                <a:latin typeface="楷体" charset="0"/>
-                <a:ea typeface="楷体" charset="0"/>
-                <a:cs typeface="楷体" charset="0"/>
-              </a:rPr>
-              <a:t/>
-            </a:r>
-            <a:r>
-              <a:rPr lang="en-US" altLang="zh-CN" sz="3000" b="1" spc="100" dirty="0">
-                <a:solidFill>
-                  <a:schemeClr val="bg1"/>
-                </a:solidFill>
-                <a:latin typeface="楷体" charset="0"/>
-                <a:ea typeface="楷体" charset="0"/>
-                <a:cs typeface="楷体" charset="0"/>
-              </a:rPr>
-              <a:t/>
-            </a:r>
-            <a:r>
-              <a:rPr lang="zh-CN" altLang="en-US" sz="3000" b="1" spc="100" dirty="0">
-                <a:solidFill>
-                  <a:schemeClr val="bg1"/>
-                </a:solidFill>
-                <a:latin typeface="楷体" charset="0"/>
-                <a:ea typeface="楷体" charset="0"/>
-                <a:cs typeface="楷体" charset="0"/>
-              </a:rPr>
-              <a:t/>
-            </a:r>
             <a:endParaRPr lang="zh-CN" altLang="en-US" sz="3000" b="1" spc="100" dirty="0">
               <a:solidFill>
                 <a:schemeClr val="bg1"/>
@@ -12652,30 +12188,6 @@
               </a:rPr>
               <a:t>1. 多轮对话式写作答疑，支持连续追问</a:t>
             </a:r>
-            <a:r>
-              <a:rPr lang="en-US" altLang="zh-CN" sz="2000" spc="100" dirty="0">
-                <a:solidFill>
-                  <a:schemeClr val="tx1"/>
-                </a:solidFill>
-                <a:latin typeface="楷体" charset="0"/>
-                <a:ea typeface="楷体" charset="0"/>
-                <a:cs typeface="楷体" charset="0"/>
-                <a:sym typeface="+mn-ea"/>
-              </a:rPr>
-              <a:t/>
-            </a:r>
-            <a:r>
-              <a:rPr lang="zh-CN" altLang="en-US" sz="2000" spc="100" dirty="0">
-                <a:solidFill>
-                  <a:schemeClr val="tx1"/>
-                </a:solidFill>
-                <a:latin typeface="楷体" charset="0"/>
-                <a:ea typeface="楷体" charset="0"/>
-                <a:cs typeface="楷体" charset="0"/>
-                <a:sym typeface="+mn-ea"/>
-              </a:rPr>
-              <a:t/>
-            </a:r>
             <a:endParaRPr lang="zh-CN" altLang="en-US" sz="2000" spc="100" dirty="0">
               <a:solidFill>
                 <a:schemeClr val="tx1"/>
@@ -12840,30 +12352,6 @@
           </a:p>
         </p:txBody>
       </p:sp>
-      <p:pic>
-        <p:nvPicPr>
-          <p:cNvPr id="26" name="Picture 25" descr="slide5_review.png"/>
-          <p:cNvPicPr>
-            <a:picLocks noChangeAspect="1"/>
-          </p:cNvPicPr>
-          <p:nvPr/>
-        </p:nvPicPr>
-        <p:blipFill>
-          <a:blip r:embed="rId3"/>
-          <a:stretch>
-            <a:fillRect/>
-          </a:stretch>
-        </p:blipFill>
-        <p:spPr>
-          <a:xfrm>
-            <a:off x="500000" y="4200000"/>
-            <a:ext cx="8500000" cy="3500000"/>
-          </a:xfrm>
-          <a:prstGeom prst="rect">
-            <a:avLst/>
-          </a:prstGeom>
-        </p:spPr>
-      </p:pic>
     </p:spTree>
   </p:cSld>
   <p:clrMapOvr>
@@ -13423,67 +12911,7 @@
                 <a:cs typeface="楷体" charset="0"/>
                 <a:sym typeface="+mn-ea"/>
               </a:rPr>
-              <a:t>应用场景概述</a:t>
-            </a:r>
-            <a:r>
-              <a:rPr lang="en-US" altLang="zh-CN" sz="2600" b="1" spc="100" dirty="0">
-                <a:solidFill>
-                  <a:srgbClr val="0070C0"/>
-                </a:solidFill>
-                <a:latin typeface="楷体" charset="0"/>
-                <a:ea typeface="楷体" charset="0"/>
-                <a:cs typeface="楷体" charset="0"/>
-                <a:sym typeface="+mn-ea"/>
-              </a:rPr>
-              <a:t/>
-            </a:r>
-            <a:r>
-              <a:rPr lang="zh-CN" altLang="en-US" sz="2600" b="1" spc="100" dirty="0">
-                <a:solidFill>
-                  <a:srgbClr val="0070C0"/>
-                </a:solidFill>
-                <a:latin typeface="楷体" charset="0"/>
-                <a:ea typeface="楷体" charset="0"/>
-                <a:cs typeface="楷体" charset="0"/>
-                <a:sym typeface="+mn-ea"/>
-              </a:rPr>
-              <a:t/>
-            </a:r>
-            <a:r>
-              <a:rPr lang="en-US" altLang="zh-CN" sz="2600" b="1" spc="100" dirty="0">
-                <a:solidFill>
-                  <a:srgbClr val="0070C0"/>
-                </a:solidFill>
-                <a:latin typeface="楷体" charset="0"/>
-                <a:ea typeface="楷体" charset="0"/>
-                <a:cs typeface="楷体" charset="0"/>
-                <a:sym typeface="+mn-ea"/>
-              </a:rPr>
-              <a:t/>
-            </a:r>
-            <a:r>
-              <a:rPr lang="zh-CN" altLang="en-US" sz="2600" b="1" spc="100" dirty="0">
-                <a:solidFill>
-                  <a:srgbClr val="0070C0"/>
-                </a:solidFill>
-                <a:latin typeface="楷体" charset="0"/>
-                <a:ea typeface="楷体" charset="0"/>
-                <a:cs typeface="楷体" charset="0"/>
-                <a:sym typeface="+mn-ea"/>
-              </a:rPr>
-              <a:t/>
-            </a:r>
-            <a:r>
-              <a:rPr lang="en-US" altLang="zh-CN" sz="2600" b="1" spc="100" dirty="0">
-                <a:solidFill>
-                  <a:srgbClr val="0070C0"/>
-                </a:solidFill>
-                <a:latin typeface="楷体" charset="0"/>
-                <a:ea typeface="楷体" charset="0"/>
-                <a:cs typeface="楷体" charset="0"/>
-                <a:sym typeface="+mn-ea"/>
-              </a:rPr>
-              <a:t/>
+              <a:t>应用场景概述 | 多设备兼容：电脑/手机/教室白板均可</a:t>
             </a:r>
             <a:endParaRPr lang="en-US" altLang="zh-CN" sz="2600" b="1" spc="100" dirty="0">
               <a:solidFill>
@@ -13650,54 +13078,6 @@
               </a:rPr>
               <a:t>习作指导课 + 课后批改 + 自主练习</a:t>
             </a:r>
-            <a:r>
-              <a:rPr lang="en-US" altLang="zh-CN" sz="2600" b="1" spc="100" dirty="0">
-                <a:solidFill>
-                  <a:srgbClr val="0070C0"/>
-                </a:solidFill>
-                <a:latin typeface="楷体" charset="0"/>
-                <a:ea typeface="楷体" charset="0"/>
-                <a:cs typeface="楷体" charset="0"/>
-                <a:sym typeface="+mn-ea"/>
-              </a:rPr>
-              <a:t/>
-            </a:r>
-            <a:r>
-              <a:rPr lang="zh-CN" altLang="en-US" sz="2600" b="1" spc="100" dirty="0">
-                <a:solidFill>
-                  <a:srgbClr val="0070C0"/>
-                </a:solidFill>
-                <a:latin typeface="楷体" charset="0"/>
-                <a:ea typeface="楷体" charset="0"/>
-                <a:cs typeface="楷体" charset="0"/>
-                <a:sym typeface="+mn-ea"/>
-              </a:rPr>
-              <a:t/>
-            </a:r>
-            <a:r>
-              <a:rPr lang="zh-CN" sz="2600" b="1" spc="100" dirty="0">
-                <a:solidFill>
-                  <a:srgbClr val="0070C0"/>
-                </a:solidFill>
-                <a:latin typeface="楷体" charset="0"/>
-                <a:ea typeface="楷体" charset="0"/>
-                <a:cs typeface="楷体" charset="0"/>
-                <a:sym typeface="+mn-ea"/>
-              </a:rPr>
-              <a:t/>
-            </a:r>
-            <a:r>
-              <a:rPr lang="en-US" altLang="zh-CN" sz="2600" b="1" spc="100" dirty="0">
-                <a:solidFill>
-                  <a:srgbClr val="0070C0"/>
-                </a:solidFill>
-                <a:latin typeface="楷体" charset="0"/>
-                <a:ea typeface="楷体" charset="0"/>
-                <a:cs typeface="楷体" charset="0"/>
-                <a:sym typeface="+mn-ea"/>
-              </a:rPr>
-              <a:t/>
-            </a:r>
             <a:endParaRPr lang="en-US" altLang="zh-CN" sz="2600" b="1" spc="100" dirty="0">
               <a:solidFill>
                 <a:srgbClr val="0070C0"/>
@@ -14073,18 +13453,6 @@
               <a:buSzTx/>
               <a:buFontTx/>
             </a:pPr>
-            <a:r>
-              <a:rPr lang="zh-CN" altLang="en-US" sz="2600" b="1" spc="100" dirty="0">
-                <a:solidFill>
-                  <a:srgbClr val="0070C0"/>
-                </a:solidFill>
-                <a:latin typeface="楷体" charset="0"/>
-                <a:ea typeface="楷体" charset="0"/>
-                <a:cs typeface="楷体" charset="0"/>
-                <a:sym typeface="+mn-ea"/>
-              </a:rPr>
-              <a:t/>
-            </a:r>
             <a:endParaRPr lang="zh-CN" altLang="en-US" sz="2600" b="1" spc="100" dirty="0">
               <a:solidFill>
                 <a:srgbClr val="0070C0"/>
@@ -15736,54 +15104,6 @@
           </p:txBody>
         </p:sp>
       </p:grpSp>
-      <p:pic>
-        <p:nvPicPr>
-          <p:cNvPr id="72" name="Picture 71" descr="data_chart.png"/>
-          <p:cNvPicPr>
-            <a:picLocks noChangeAspect="1"/>
-          </p:cNvPicPr>
-          <p:nvPr/>
-        </p:nvPicPr>
-        <p:blipFill>
-          <a:blip r:embed="rId27"/>
-          <a:stretch>
-            <a:fillRect/>
-          </a:stretch>
-        </p:blipFill>
-        <p:spPr>
-          <a:xfrm>
-            <a:off x="500000" y="4200000"/>
-            <a:ext cx="8500000" cy="3500000"/>
-          </a:xfrm>
-          <a:prstGeom prst="rect">
-            <a:avLst/>
-          </a:prstGeom>
-        </p:spPr>
-      </p:pic>
-      <p:pic>
-        <p:nvPicPr>
-          <p:cNvPr id="73" name="Picture 72" descr="slide6_samples.png"/>
-          <p:cNvPicPr>
-            <a:picLocks noChangeAspect="1"/>
-          </p:cNvPicPr>
-          <p:nvPr/>
-        </p:nvPicPr>
-        <p:blipFill>
-          <a:blip r:embed="rId28"/>
-          <a:stretch>
-            <a:fillRect/>
-          </a:stretch>
-        </p:blipFill>
-        <p:spPr>
-          <a:xfrm>
-            <a:off x="500000" y="4200000"/>
-            <a:ext cx="8500000" cy="3500000"/>
-          </a:xfrm>
-          <a:prstGeom prst="rect">
-            <a:avLst/>
-          </a:prstGeom>
-        </p:spPr>
-      </p:pic>
     </p:spTree>
   </p:cSld>
   <p:clrMapOvr>
@@ -15977,42 +15297,6 @@
               </a:rPr>
               <a:t>一、课堂应用</a:t>
             </a:r>
-            <a:r>
-              <a:rPr lang="zh-CN" sz="3000" b="1" spc="100" dirty="0">
-                <a:solidFill>
-                  <a:schemeClr val="bg1"/>
-                </a:solidFill>
-                <a:latin typeface="楷体" charset="0"/>
-                <a:ea typeface="楷体" charset="0"/>
-                <a:cs typeface="楷体" charset="0"/>
-                <a:sym typeface="+mn-ea"/>
-              </a:rPr>
-              <a:t/>
-            </a:r>
-            <a:r>
-              <a:rPr lang="en-US" altLang="zh-CN" sz="3000" b="1" spc="100" dirty="0">
-                <a:solidFill>
-                  <a:schemeClr val="bg1"/>
-                </a:solidFill>
-                <a:latin typeface="楷体" charset="0"/>
-                <a:ea typeface="楷体" charset="0"/>
-                <a:cs typeface="楷体" charset="0"/>
-                <a:sym typeface="+mn-ea"/>
-              </a:rPr>
-              <a:t/>
-            </a:r>
-            <a:r>
-              <a:rPr lang="zh-CN" altLang="en-US" sz="3000" b="1" spc="100" dirty="0">
-                <a:solidFill>
-                  <a:schemeClr val="bg1"/>
-                </a:solidFill>
-                <a:latin typeface="楷体" charset="0"/>
-                <a:ea typeface="楷体" charset="0"/>
-                <a:cs typeface="楷体" charset="0"/>
-                <a:sym typeface="+mn-ea"/>
-              </a:rPr>
-              <a:t/>
-            </a:r>
             <a:endParaRPr lang="zh-CN" altLang="en-US" sz="3000" b="1" spc="100" dirty="0">
               <a:solidFill>
                 <a:schemeClr val="bg1"/>
@@ -16468,30 +15752,6 @@
                 <a:sym typeface="+mn-ea"/>
               </a:rPr>
               <a:t>1. 习作指导课：AI一对一辅导，每个学生都有针对性建议</a:t>
-            </a:r>
-            <a:r>
-              <a:rPr lang="en-US" altLang="zh-CN" sz="2000" spc="100" dirty="0">
-                <a:solidFill>
-                  <a:schemeClr val="tx1"/>
-                </a:solidFill>
-                <a:latin typeface="楷体" charset="0"/>
-                <a:ea typeface="楷体" charset="0"/>
-                <a:cs typeface="楷体" charset="0"/>
-                <a:sym typeface="+mn-ea"/>
-              </a:rPr>
-              <a:t/>
-            </a:r>
-            <a:r>
-              <a:rPr lang="zh-CN" altLang="en-US" sz="2000" spc="100" dirty="0">
-                <a:solidFill>
-                  <a:schemeClr val="tx1"/>
-                </a:solidFill>
-                <a:latin typeface="楷体" charset="0"/>
-                <a:ea typeface="楷体" charset="0"/>
-                <a:cs typeface="楷体" charset="0"/>
-                <a:sym typeface="+mn-ea"/>
-              </a:rPr>
-              <a:t/>
             </a:r>
             <a:endParaRPr lang="zh-CN" altLang="en-US" sz="2000" spc="100" dirty="0">
               <a:solidFill>
@@ -16703,39 +15963,6 @@
               </a:rPr>
               <a:t>二、创新与合规</a:t>
             </a:r>
-            <a:r>
-              <a:rPr lang="zh-CN" sz="3000" b="1" spc="100" dirty="0">
-                <a:solidFill>
-                  <a:schemeClr val="bg1"/>
-                </a:solidFill>
-                <a:latin typeface="楷体" charset="0"/>
-                <a:ea typeface="楷体" charset="0"/>
-                <a:cs typeface="楷体" charset="0"/>
-              </a:rPr>
-              <a:t/>
-            </a:r>
-            <a:r>
-              <a:rPr lang="en-US" altLang="zh-CN" sz="3000" b="1" spc="100" dirty="0">
-                <a:solidFill>
-                  <a:schemeClr val="bg1"/>
-                </a:solidFill>
-                <a:latin typeface="楷体" charset="0"/>
-                <a:ea typeface="楷体" charset="0"/>
-                <a:cs typeface="楷体" charset="0"/>
-              </a:rPr>
-              <a:t/>
-            </a:r>
-            <a:r>
-              <a:rPr lang="zh-CN" altLang="en-US" sz="3000" b="1" spc="100" dirty="0">
-                <a:solidFill>
-                  <a:schemeClr val="bg1"/>
-                </a:solidFill>
-                <a:latin typeface="楷体" charset="0"/>
-                <a:ea typeface="楷体" charset="0"/>
-                <a:cs typeface="楷体" charset="0"/>
-              </a:rPr>
-              <a:t/>
-            </a:r>
             <a:endParaRPr lang="zh-CN" altLang="en-US" sz="3000" b="1" spc="100" dirty="0">
               <a:solidFill>
                 <a:schemeClr val="bg1"/>
@@ -17038,30 +16265,6 @@
                 <a:sym typeface="+mn-ea"/>
               </a:rPr>
               <a:t>1. 一生一导个性化教学 + 精准聚焦高频痛点 + 严格遵循AI使用指南</a:t>
-            </a:r>
-            <a:r>
-              <a:rPr lang="en-US" altLang="zh-CN" sz="2000" spc="100" dirty="0">
-                <a:solidFill>
-                  <a:schemeClr val="tx1"/>
-                </a:solidFill>
-                <a:latin typeface="楷体" charset="0"/>
-                <a:ea typeface="楷体" charset="0"/>
-                <a:cs typeface="楷体" charset="0"/>
-                <a:sym typeface="+mn-ea"/>
-              </a:rPr>
-              <a:t/>
-            </a:r>
-            <a:r>
-              <a:rPr lang="zh-CN" altLang="en-US" sz="2000" spc="100" dirty="0">
-                <a:solidFill>
-                  <a:schemeClr val="tx1"/>
-                </a:solidFill>
-                <a:latin typeface="楷体" charset="0"/>
-                <a:ea typeface="楷体" charset="0"/>
-                <a:cs typeface="楷体" charset="0"/>
-                <a:sym typeface="+mn-ea"/>
-              </a:rPr>
-              <a:t/>
             </a:r>
             <a:endParaRPr lang="zh-CN" altLang="en-US" sz="2000" spc="100" dirty="0">
               <a:solidFill>
@@ -17331,6 +16534,7 @@
               <a:rPr sz="1200"/>
               <a:t>GitHub: github.com/707978439-cpu/animal-writing-assistant</a:t>
             </a:r>
+            <a:endParaRPr sz="1200"/>
           </a:p>
         </p:txBody>
       </p:sp>

</xml_diff>

<commit_message>
PPT: text-only update, multi-device info, no images
</commit_message>
<xml_diff>
--- a/演示视频PPT.pptx
+++ b/演示视频PPT.pptx
@@ -122,7 +122,7 @@
   <p:extLst>
     <p:ext uri="{EFAFB233-063F-42B5-8137-9DF3F51BA10A}">
       <p15:sldGuideLst xmlns:p15="http://schemas.microsoft.com/office/powerpoint/2012/main">
-        <p15:guide id="1" orient="horz" pos="2237" userDrawn="1">
+        <p15:guide id="1" orient="horz" pos="2236" userDrawn="1">
           <p15:clr>
             <a:srgbClr val="A4A3A4"/>
           </p15:clr>
@@ -5563,7 +5563,7 @@
         <a:spcBef>
           <a:spcPts val="1000"/>
         </a:spcBef>
-        <a:buFont typeface="Arial" panose="020B0604020202090204" pitchFamily="34" charset="0"/>
+        <a:buFont typeface="Arial" panose="02080604020202020204" pitchFamily="34" charset="0"/>
         <a:buChar char="•"/>
         <a:defRPr sz="2800" kern="1200">
           <a:solidFill>
@@ -5581,7 +5581,7 @@
         <a:spcBef>
           <a:spcPts val="500"/>
         </a:spcBef>
-        <a:buFont typeface="Arial" panose="020B0604020202090204" pitchFamily="34" charset="0"/>
+        <a:buFont typeface="Arial" panose="02080604020202020204" pitchFamily="34" charset="0"/>
         <a:buChar char="•"/>
         <a:defRPr sz="2400" kern="1200">
           <a:solidFill>
@@ -5599,7 +5599,7 @@
         <a:spcBef>
           <a:spcPts val="500"/>
         </a:spcBef>
-        <a:buFont typeface="Arial" panose="020B0604020202090204" pitchFamily="34" charset="0"/>
+        <a:buFont typeface="Arial" panose="02080604020202020204" pitchFamily="34" charset="0"/>
         <a:buChar char="•"/>
         <a:defRPr sz="2000" kern="1200">
           <a:solidFill>
@@ -5617,7 +5617,7 @@
         <a:spcBef>
           <a:spcPts val="500"/>
         </a:spcBef>
-        <a:buFont typeface="Arial" panose="020B0604020202090204" pitchFamily="34" charset="0"/>
+        <a:buFont typeface="Arial" panose="02080604020202020204" pitchFamily="34" charset="0"/>
         <a:buChar char="•"/>
         <a:defRPr sz="1800" kern="1200">
           <a:solidFill>
@@ -5635,7 +5635,7 @@
         <a:spcBef>
           <a:spcPts val="500"/>
         </a:spcBef>
-        <a:buFont typeface="Arial" panose="020B0604020202090204" pitchFamily="34" charset="0"/>
+        <a:buFont typeface="Arial" panose="02080604020202020204" pitchFamily="34" charset="0"/>
         <a:buChar char="•"/>
         <a:defRPr sz="1800" kern="1200">
           <a:solidFill>
@@ -5653,7 +5653,7 @@
         <a:spcBef>
           <a:spcPts val="500"/>
         </a:spcBef>
-        <a:buFont typeface="Arial" panose="020B0604020202090204" pitchFamily="34" charset="0"/>
+        <a:buFont typeface="Arial" panose="02080604020202020204" pitchFamily="34" charset="0"/>
         <a:buChar char="•"/>
         <a:defRPr sz="1800" kern="1200">
           <a:solidFill>
@@ -5671,7 +5671,7 @@
         <a:spcBef>
           <a:spcPts val="500"/>
         </a:spcBef>
-        <a:buFont typeface="Arial" panose="020B0604020202090204" pitchFamily="34" charset="0"/>
+        <a:buFont typeface="Arial" panose="02080604020202020204" pitchFamily="34" charset="0"/>
         <a:buChar char="•"/>
         <a:defRPr sz="1800" kern="1200">
           <a:solidFill>
@@ -5689,7 +5689,7 @@
         <a:spcBef>
           <a:spcPts val="500"/>
         </a:spcBef>
-        <a:buFont typeface="Arial" panose="020B0604020202090204" pitchFamily="34" charset="0"/>
+        <a:buFont typeface="Arial" panose="02080604020202020204" pitchFamily="34" charset="0"/>
         <a:buChar char="•"/>
         <a:defRPr sz="1800" kern="1200">
           <a:solidFill>
@@ -5707,7 +5707,7 @@
         <a:spcBef>
           <a:spcPts val="500"/>
         </a:spcBef>
-        <a:buFont typeface="Arial" panose="020B0604020202090204" pitchFamily="34" charset="0"/>
+        <a:buFont typeface="Arial" panose="02080604020202020204" pitchFamily="34" charset="0"/>
         <a:buChar char="•"/>
         <a:defRPr sz="1800" kern="1200">
           <a:solidFill>
@@ -6112,7 +6112,7 @@
         <a:spcBef>
           <a:spcPts val="1000"/>
         </a:spcBef>
-        <a:buFont typeface="Arial" panose="020B0604020202090204" pitchFamily="34" charset="0"/>
+        <a:buFont typeface="Arial" panose="02080604020202020204" pitchFamily="34" charset="0"/>
         <a:buChar char="•"/>
         <a:defRPr sz="2800" kern="1200">
           <a:solidFill>
@@ -6130,7 +6130,7 @@
         <a:spcBef>
           <a:spcPts val="500"/>
         </a:spcBef>
-        <a:buFont typeface="Arial" panose="020B0604020202090204" pitchFamily="34" charset="0"/>
+        <a:buFont typeface="Arial" panose="02080604020202020204" pitchFamily="34" charset="0"/>
         <a:buChar char="•"/>
         <a:defRPr sz="2400" kern="1200">
           <a:solidFill>
@@ -6148,7 +6148,7 @@
         <a:spcBef>
           <a:spcPts val="500"/>
         </a:spcBef>
-        <a:buFont typeface="Arial" panose="020B0604020202090204" pitchFamily="34" charset="0"/>
+        <a:buFont typeface="Arial" panose="02080604020202020204" pitchFamily="34" charset="0"/>
         <a:buChar char="•"/>
         <a:defRPr sz="2000" kern="1200">
           <a:solidFill>
@@ -6166,7 +6166,7 @@
         <a:spcBef>
           <a:spcPts val="500"/>
         </a:spcBef>
-        <a:buFont typeface="Arial" panose="020B0604020202090204" pitchFamily="34" charset="0"/>
+        <a:buFont typeface="Arial" panose="02080604020202020204" pitchFamily="34" charset="0"/>
         <a:buChar char="•"/>
         <a:defRPr sz="1800" kern="1200">
           <a:solidFill>
@@ -6184,7 +6184,7 @@
         <a:spcBef>
           <a:spcPts val="500"/>
         </a:spcBef>
-        <a:buFont typeface="Arial" panose="020B0604020202090204" pitchFamily="34" charset="0"/>
+        <a:buFont typeface="Arial" panose="02080604020202020204" pitchFamily="34" charset="0"/>
         <a:buChar char="•"/>
         <a:defRPr sz="1800" kern="1200">
           <a:solidFill>
@@ -6202,7 +6202,7 @@
         <a:spcBef>
           <a:spcPts val="500"/>
         </a:spcBef>
-        <a:buFont typeface="Arial" panose="020B0604020202090204" pitchFamily="34" charset="0"/>
+        <a:buFont typeface="Arial" panose="02080604020202020204" pitchFamily="34" charset="0"/>
         <a:buChar char="•"/>
         <a:defRPr sz="1800" kern="1200">
           <a:solidFill>
@@ -6220,7 +6220,7 @@
         <a:spcBef>
           <a:spcPts val="500"/>
         </a:spcBef>
-        <a:buFont typeface="Arial" panose="020B0604020202090204" pitchFamily="34" charset="0"/>
+        <a:buFont typeface="Arial" panose="02080604020202020204" pitchFamily="34" charset="0"/>
         <a:buChar char="•"/>
         <a:defRPr sz="1800" kern="1200">
           <a:solidFill>
@@ -6238,7 +6238,7 @@
         <a:spcBef>
           <a:spcPts val="500"/>
         </a:spcBef>
-        <a:buFont typeface="Arial" panose="020B0604020202090204" pitchFamily="34" charset="0"/>
+        <a:buFont typeface="Arial" panose="02080604020202020204" pitchFamily="34" charset="0"/>
         <a:buChar char="•"/>
         <a:defRPr sz="1800" kern="1200">
           <a:solidFill>
@@ -6256,7 +6256,7 @@
         <a:spcBef>
           <a:spcPts val="500"/>
         </a:spcBef>
-        <a:buFont typeface="Arial" panose="020B0604020202090204" pitchFamily="34" charset="0"/>
+        <a:buFont typeface="Arial" panose="02080604020202020204" pitchFamily="34" charset="0"/>
         <a:buChar char="•"/>
         <a:defRPr sz="1800" kern="1200">
           <a:solidFill>
@@ -6846,6 +6846,50 @@
               </a:rPr>
               <a:t>动物习作AI智能助教</a:t>
             </a:r>
+            <a:r>
+              <a:rPr lang="en-US" altLang="zh-CN" sz="4000" b="1" spc="100" dirty="0">
+                <a:solidFill>
+                  <a:schemeClr val="bg1"/>
+                </a:solidFill>
+                <a:latin typeface="楷体" charset="0"/>
+                <a:ea typeface="楷体" charset="0"/>
+                <a:cs typeface="楷体" charset="0"/>
+              </a:rPr>
+              <a:t/>
+            </a:r>
+            <a:r>
+              <a:rPr lang="zh-CN" altLang="en-US" sz="4000" b="1" spc="100" dirty="0">
+                <a:solidFill>
+                  <a:schemeClr val="bg1"/>
+                </a:solidFill>
+                <a:latin typeface="楷体" charset="0"/>
+                <a:ea typeface="楷体" charset="0"/>
+                <a:cs typeface="楷体" charset="0"/>
+              </a:rPr>
+              <a:t/>
+            </a:r>
+            <a:r>
+              <a:rPr lang="en-US" altLang="zh-CN" sz="4000" b="1" spc="100" dirty="0">
+                <a:solidFill>
+                  <a:schemeClr val="bg1"/>
+                </a:solidFill>
+                <a:latin typeface="楷体" charset="0"/>
+                <a:ea typeface="楷体" charset="0"/>
+                <a:cs typeface="楷体" charset="0"/>
+              </a:rPr>
+              <a:t/>
+            </a:r>
+            <a:r>
+              <a:rPr lang="zh-CN" altLang="en-US" sz="4000" b="1" spc="100" dirty="0">
+                <a:solidFill>
+                  <a:schemeClr val="bg1"/>
+                </a:solidFill>
+                <a:latin typeface="楷体" charset="0"/>
+                <a:ea typeface="楷体" charset="0"/>
+                <a:cs typeface="楷体" charset="0"/>
+              </a:rPr>
+              <a:t/>
+            </a:r>
             <a:endParaRPr lang="zh-CN" altLang="en-US" sz="4000" b="1" spc="100" dirty="0">
               <a:solidFill>
                 <a:schemeClr val="bg1"/>
@@ -7002,6 +7046,54 @@
               </a:rPr>
               <a:t>惠州市富民小学</a:t>
             </a:r>
+            <a:r>
+              <a:rPr lang="en-US" altLang="zh-CN" sz="2400" b="1" spc="100" dirty="0">
+                <a:solidFill>
+                  <a:schemeClr val="bg1"/>
+                </a:solidFill>
+                <a:latin typeface="楷体" charset="0"/>
+                <a:ea typeface="楷体" charset="0"/>
+                <a:cs typeface="楷体" charset="0"/>
+                <a:sym typeface="+mn-ea"/>
+              </a:rPr>
+              <a:t/>
+            </a:r>
+            <a:r>
+              <a:rPr lang="zh-CN" altLang="en-US" sz="2400" b="1" spc="100" dirty="0">
+                <a:solidFill>
+                  <a:schemeClr val="bg1"/>
+                </a:solidFill>
+                <a:latin typeface="楷体" charset="0"/>
+                <a:ea typeface="楷体" charset="0"/>
+                <a:cs typeface="楷体" charset="0"/>
+                <a:sym typeface="+mn-ea"/>
+              </a:rPr>
+              <a:t/>
+            </a:r>
+            <a:r>
+              <a:rPr lang="en-US" altLang="zh-CN" sz="2400" b="1" spc="100" dirty="0">
+                <a:solidFill>
+                  <a:schemeClr val="bg1"/>
+                </a:solidFill>
+                <a:latin typeface="楷体" charset="0"/>
+                <a:ea typeface="楷体" charset="0"/>
+                <a:cs typeface="楷体" charset="0"/>
+                <a:sym typeface="+mn-ea"/>
+              </a:rPr>
+              <a:t/>
+            </a:r>
+            <a:r>
+              <a:rPr lang="zh-CN" altLang="en-US" sz="2400" b="1" spc="100" dirty="0">
+                <a:solidFill>
+                  <a:schemeClr val="bg1"/>
+                </a:solidFill>
+                <a:latin typeface="楷体" charset="0"/>
+                <a:ea typeface="楷体" charset="0"/>
+                <a:cs typeface="楷体" charset="0"/>
+                <a:sym typeface="+mn-ea"/>
+              </a:rPr>
+              <a:t/>
+            </a:r>
             <a:endParaRPr lang="zh-CN" altLang="en-US" sz="2400" b="1" spc="100" dirty="0">
               <a:solidFill>
                 <a:schemeClr val="bg1"/>
@@ -7171,6 +7263,94 @@
                 <a:cs typeface="楷体" charset="0"/>
               </a:rPr>
               <a:t>许志超</a:t>
+            </a:r>
+            <a:r>
+              <a:rPr lang="zh-CN" altLang="en-US" sz="2400" b="1" spc="100" dirty="0">
+                <a:solidFill>
+                  <a:schemeClr val="bg1"/>
+                </a:solidFill>
+                <a:latin typeface="楷体" charset="0"/>
+                <a:ea typeface="楷体" charset="0"/>
+                <a:cs typeface="楷体" charset="0"/>
+              </a:rPr>
+              <a:t/>
+            </a:r>
+            <a:r>
+              <a:rPr lang="en-US" altLang="zh-CN" sz="2400" b="1" spc="100" dirty="0">
+                <a:solidFill>
+                  <a:schemeClr val="bg1"/>
+                </a:solidFill>
+                <a:latin typeface="楷体" charset="0"/>
+                <a:ea typeface="楷体" charset="0"/>
+                <a:cs typeface="楷体" charset="0"/>
+              </a:rPr>
+              <a:t/>
+            </a:r>
+            <a:r>
+              <a:rPr lang="zh-CN" altLang="en-US" sz="2400" b="1" spc="100" dirty="0">
+                <a:solidFill>
+                  <a:schemeClr val="bg1"/>
+                </a:solidFill>
+                <a:latin typeface="楷体" charset="0"/>
+                <a:ea typeface="楷体" charset="0"/>
+                <a:cs typeface="楷体" charset="0"/>
+              </a:rPr>
+              <a:t/>
+            </a:r>
+            <a:r>
+              <a:rPr lang="en-US" altLang="zh-CN" sz="2400" b="1" spc="100" dirty="0">
+                <a:solidFill>
+                  <a:schemeClr val="bg1"/>
+                </a:solidFill>
+                <a:latin typeface="楷体" charset="0"/>
+                <a:ea typeface="楷体" charset="0"/>
+                <a:cs typeface="楷体" charset="0"/>
+              </a:rPr>
+              <a:t/>
+            </a:r>
+            <a:r>
+              <a:rPr lang="zh-CN" altLang="en-US" sz="2400" b="1" spc="100" dirty="0">
+                <a:solidFill>
+                  <a:schemeClr val="bg1"/>
+                </a:solidFill>
+                <a:latin typeface="楷体" charset="0"/>
+                <a:ea typeface="楷体" charset="0"/>
+                <a:cs typeface="楷体" charset="0"/>
+              </a:rPr>
+              <a:t/>
+            </a:r>
+            <a:r>
+              <a:rPr lang="en-US" altLang="zh-CN" sz="2400" b="1" spc="100" dirty="0">
+                <a:solidFill>
+                  <a:schemeClr val="bg1"/>
+                </a:solidFill>
+                <a:latin typeface="楷体" charset="0"/>
+                <a:ea typeface="楷体" charset="0"/>
+                <a:cs typeface="楷体" charset="0"/>
+              </a:rPr>
+              <a:t/>
+            </a:r>
+            <a:r>
+              <a:rPr lang="zh-CN" altLang="en-US" sz="2400" b="1" spc="100" dirty="0">
+                <a:solidFill>
+                  <a:schemeClr val="bg1"/>
+                </a:solidFill>
+                <a:latin typeface="楷体" charset="0"/>
+                <a:ea typeface="楷体" charset="0"/>
+                <a:cs typeface="楷体" charset="0"/>
+              </a:rPr>
+              <a:t/>
+            </a:r>
+            <a:r>
+              <a:rPr lang="en-US" altLang="zh-CN" sz="2400" b="1" spc="100" dirty="0">
+                <a:solidFill>
+                  <a:schemeClr val="bg1"/>
+                </a:solidFill>
+                <a:latin typeface="楷体" charset="0"/>
+                <a:ea typeface="楷体" charset="0"/>
+                <a:cs typeface="楷体" charset="0"/>
+              </a:rPr>
+              <a:t/>
             </a:r>
             <a:endParaRPr lang="en-US" altLang="zh-CN" sz="2400" b="1" spc="100" dirty="0">
               <a:solidFill>
@@ -7849,7 +8029,7 @@
               <a:t>1. 痛点：四年级动物类习作，教师无法兼顾48人个性化指导
 2. 方案：基于DeepSeek V4 Pro大模型，自主开发AI教育智能体
 3. 功能：写作指导、作文批改、互动问答、范文展示
-4. 成果：学生习作字数提升32%，批改效率提升60%，并部署至</a:t>
+4. 成果：学生习作字数提升32%，批改效率提升60%，并部署至扣子平台 | 兼容电脑/手机/希沃白板，多设备同时访问</a:t>
             </a:r>
             <a:r>
               <a:rPr lang="en-US" altLang="zh-CN" sz="2400" spc="100" dirty="0">
@@ -7860,7 +8040,7 @@
                 <a:ea typeface="楷体" charset="0"/>
                 <a:cs typeface="楷体" charset="0"/>
               </a:rPr>
-              <a:t>github</a:t>
+              <a:t/>
             </a:r>
             <a:r>
               <a:rPr lang="zh-CN" altLang="en-US" sz="2400" spc="100" dirty="0">
@@ -7871,29 +8051,7 @@
                 <a:ea typeface="楷体" charset="0"/>
                 <a:cs typeface="楷体" charset="0"/>
               </a:rPr>
-              <a:t>代码共享平台</a:t>
-            </a:r>
-            <a:r>
-              <a:rPr lang="zh-CN" altLang="en-US" sz="2400" spc="100" dirty="0">
-                <a:solidFill>
-                  <a:schemeClr val="tx1"/>
-                </a:solidFill>
-                <a:latin typeface="楷体" charset="0"/>
-                <a:ea typeface="楷体" charset="0"/>
-                <a:cs typeface="楷体" charset="0"/>
-              </a:rPr>
-              <a:t>以及国内广泛应用</a:t>
-            </a:r>
-            <a:r>
-              <a:rPr lang="zh-CN" altLang="en-US" sz="2400" spc="100" dirty="0">
-                <a:solidFill>
-                  <a:schemeClr val="tx1"/>
-                </a:solidFill>
-                <a:latin typeface="楷体" charset="0"/>
-                <a:ea typeface="楷体" charset="0"/>
-                <a:cs typeface="楷体" charset="0"/>
-              </a:rPr>
-              <a:t>的扣子平台 | 兼容电脑/手机/希沃白板，多设备同时访问</a:t>
+              <a:t/>
             </a:r>
             <a:endParaRPr lang="zh-CN" altLang="en-US" sz="2400" spc="100" dirty="0">
               <a:solidFill>
@@ -8843,6 +9001,66 @@
               </a:rPr>
               <a:t>写作闯关模块</a:t>
             </a:r>
+            <a:r>
+              <a:rPr lang="en-US" altLang="zh-CN" sz="2600" b="1" spc="100" dirty="0">
+                <a:solidFill>
+                  <a:srgbClr val="0070C0"/>
+                </a:solidFill>
+                <a:latin typeface="楷体" charset="0"/>
+                <a:ea typeface="楷体" charset="0"/>
+                <a:cs typeface="楷体" charset="0"/>
+                <a:sym typeface="+mn-ea"/>
+              </a:rPr>
+              <a:t/>
+            </a:r>
+            <a:r>
+              <a:rPr lang="zh-CN" altLang="en-US" sz="2600" b="1" spc="100" dirty="0">
+                <a:solidFill>
+                  <a:srgbClr val="0070C0"/>
+                </a:solidFill>
+                <a:latin typeface="楷体" charset="0"/>
+                <a:ea typeface="楷体" charset="0"/>
+                <a:cs typeface="楷体" charset="0"/>
+                <a:sym typeface="+mn-ea"/>
+              </a:rPr>
+              <a:t/>
+            </a:r>
+            <a:r>
+              <a:rPr lang="en-US" altLang="zh-CN" sz="2600" b="1" spc="100" dirty="0">
+                <a:solidFill>
+                  <a:srgbClr val="0070C0"/>
+                </a:solidFill>
+                <a:latin typeface="楷体" charset="0"/>
+                <a:ea typeface="楷体" charset="0"/>
+                <a:cs typeface="楷体" charset="0"/>
+                <a:sym typeface="+mn-ea"/>
+              </a:rPr>
+              <a:t/>
+            </a:r>
+            <a:r>
+              <a:rPr lang="zh-CN" altLang="en-US" sz="2600" b="1" spc="100" dirty="0">
+                <a:solidFill>
+                  <a:srgbClr val="0070C0"/>
+                </a:solidFill>
+                <a:latin typeface="楷体" charset="0"/>
+                <a:ea typeface="楷体" charset="0"/>
+                <a:cs typeface="楷体" charset="0"/>
+                <a:sym typeface="+mn-ea"/>
+              </a:rPr>
+              <a:t/>
+            </a:r>
+            <a:r>
+              <a:rPr lang="en-US" altLang="zh-CN" sz="2600" b="1" spc="100" dirty="0">
+                <a:solidFill>
+                  <a:srgbClr val="0070C0"/>
+                </a:solidFill>
+                <a:latin typeface="楷体" charset="0"/>
+                <a:ea typeface="楷体" charset="0"/>
+                <a:cs typeface="楷体" charset="0"/>
+                <a:sym typeface="+mn-ea"/>
+              </a:rPr>
+              <a:t/>
+            </a:r>
             <a:endParaRPr lang="en-US" altLang="zh-CN" sz="2600" b="1" spc="100" dirty="0">
               <a:solidFill>
                 <a:srgbClr val="0070C0"/>
@@ -9008,6 +9226,54 @@
               </a:rPr>
               <a:t>五步引导式写作：选动物→外形→习性→故事→完成</a:t>
             </a:r>
+            <a:r>
+              <a:rPr lang="en-US" altLang="zh-CN" sz="2600" b="1" spc="100" dirty="0">
+                <a:solidFill>
+                  <a:srgbClr val="0070C0"/>
+                </a:solidFill>
+                <a:latin typeface="楷体" charset="0"/>
+                <a:ea typeface="楷体" charset="0"/>
+                <a:cs typeface="楷体" charset="0"/>
+                <a:sym typeface="+mn-ea"/>
+              </a:rPr>
+              <a:t/>
+            </a:r>
+            <a:r>
+              <a:rPr lang="zh-CN" altLang="en-US" sz="2600" b="1" spc="100" dirty="0">
+                <a:solidFill>
+                  <a:srgbClr val="0070C0"/>
+                </a:solidFill>
+                <a:latin typeface="楷体" charset="0"/>
+                <a:ea typeface="楷体" charset="0"/>
+                <a:cs typeface="楷体" charset="0"/>
+                <a:sym typeface="+mn-ea"/>
+              </a:rPr>
+              <a:t/>
+            </a:r>
+            <a:r>
+              <a:rPr lang="zh-CN" sz="2600" b="1" spc="100" dirty="0">
+                <a:solidFill>
+                  <a:srgbClr val="0070C0"/>
+                </a:solidFill>
+                <a:latin typeface="楷体" charset="0"/>
+                <a:ea typeface="楷体" charset="0"/>
+                <a:cs typeface="楷体" charset="0"/>
+                <a:sym typeface="+mn-ea"/>
+              </a:rPr>
+              <a:t/>
+            </a:r>
+            <a:r>
+              <a:rPr lang="en-US" altLang="zh-CN" sz="2600" b="1" spc="100" dirty="0">
+                <a:solidFill>
+                  <a:srgbClr val="0070C0"/>
+                </a:solidFill>
+                <a:latin typeface="楷体" charset="0"/>
+                <a:ea typeface="楷体" charset="0"/>
+                <a:cs typeface="楷体" charset="0"/>
+                <a:sym typeface="+mn-ea"/>
+              </a:rPr>
+              <a:t/>
+            </a:r>
             <a:endParaRPr lang="en-US" altLang="zh-CN" sz="2600" b="1" spc="100" dirty="0">
               <a:solidFill>
                 <a:srgbClr val="0070C0"/>
@@ -9383,6 +9649,18 @@
               <a:buSzTx/>
               <a:buFontTx/>
             </a:pPr>
+            <a:r>
+              <a:rPr lang="zh-CN" altLang="en-US" sz="2600" b="1" spc="100" dirty="0">
+                <a:solidFill>
+                  <a:srgbClr val="0070C0"/>
+                </a:solidFill>
+                <a:latin typeface="楷体" charset="0"/>
+                <a:ea typeface="楷体" charset="0"/>
+                <a:cs typeface="楷体" charset="0"/>
+                <a:sym typeface="+mn-ea"/>
+              </a:rPr>
+              <a:t/>
+            </a:r>
             <a:endParaRPr lang="zh-CN" altLang="en-US" sz="2600" b="1" spc="100" dirty="0">
               <a:solidFill>
                 <a:srgbClr val="0070C0"/>
@@ -11226,6 +11504,39 @@
               </a:rPr>
               <a:t>一、写作指导</a:t>
             </a:r>
+            <a:r>
+              <a:rPr lang="zh-CN" sz="3000" b="1" spc="100" dirty="0">
+                <a:solidFill>
+                  <a:schemeClr val="bg1"/>
+                </a:solidFill>
+                <a:latin typeface="楷体" charset="0"/>
+                <a:ea typeface="楷体" charset="0"/>
+                <a:cs typeface="楷体" charset="0"/>
+              </a:rPr>
+              <a:t/>
+            </a:r>
+            <a:r>
+              <a:rPr lang="en-US" altLang="zh-CN" sz="3000" b="1" spc="100" dirty="0">
+                <a:solidFill>
+                  <a:schemeClr val="bg1"/>
+                </a:solidFill>
+                <a:latin typeface="楷体" charset="0"/>
+                <a:ea typeface="楷体" charset="0"/>
+                <a:cs typeface="楷体" charset="0"/>
+              </a:rPr>
+              <a:t/>
+            </a:r>
+            <a:r>
+              <a:rPr lang="zh-CN" altLang="en-US" sz="3000" b="1" spc="100" dirty="0">
+                <a:solidFill>
+                  <a:schemeClr val="bg1"/>
+                </a:solidFill>
+                <a:latin typeface="楷体" charset="0"/>
+                <a:ea typeface="楷体" charset="0"/>
+                <a:cs typeface="楷体" charset="0"/>
+              </a:rPr>
+              <a:t/>
+            </a:r>
             <a:endParaRPr lang="zh-CN" altLang="en-US" sz="3000" b="1" spc="100" dirty="0">
               <a:solidFill>
                 <a:schemeClr val="bg1"/>
@@ -11681,6 +11992,30 @@
                 <a:sym typeface="+mn-ea"/>
               </a:rPr>
               <a:t>1. 粘贴习作，AI从内容/语言/情感多维度分析</a:t>
+            </a:r>
+            <a:r>
+              <a:rPr lang="en-US" altLang="zh-CN" sz="2000" spc="100" dirty="0">
+                <a:solidFill>
+                  <a:schemeClr val="tx1"/>
+                </a:solidFill>
+                <a:latin typeface="楷体" charset="0"/>
+                <a:ea typeface="楷体" charset="0"/>
+                <a:cs typeface="楷体" charset="0"/>
+                <a:sym typeface="+mn-ea"/>
+              </a:rPr>
+              <a:t/>
+            </a:r>
+            <a:r>
+              <a:rPr lang="zh-CN" altLang="en-US" sz="2000" spc="100" dirty="0">
+                <a:solidFill>
+                  <a:schemeClr val="tx1"/>
+                </a:solidFill>
+                <a:latin typeface="楷体" charset="0"/>
+                <a:ea typeface="楷体" charset="0"/>
+                <a:cs typeface="楷体" charset="0"/>
+                <a:sym typeface="+mn-ea"/>
+              </a:rPr>
+              <a:t/>
             </a:r>
             <a:endParaRPr lang="zh-CN" altLang="en-US" sz="2000" spc="100" dirty="0">
               <a:solidFill>
@@ -11885,6 +12220,39 @@
               </a:rPr>
               <a:t>二、互动问答与范文展示，标注年级和字数</a:t>
             </a:r>
+            <a:r>
+              <a:rPr lang="zh-CN" sz="3000" b="1" spc="100" dirty="0">
+                <a:solidFill>
+                  <a:schemeClr val="bg1"/>
+                </a:solidFill>
+                <a:latin typeface="楷体" charset="0"/>
+                <a:ea typeface="楷体" charset="0"/>
+                <a:cs typeface="楷体" charset="0"/>
+              </a:rPr>
+              <a:t/>
+            </a:r>
+            <a:r>
+              <a:rPr lang="en-US" altLang="zh-CN" sz="3000" b="1" spc="100" dirty="0">
+                <a:solidFill>
+                  <a:schemeClr val="bg1"/>
+                </a:solidFill>
+                <a:latin typeface="楷体" charset="0"/>
+                <a:ea typeface="楷体" charset="0"/>
+                <a:cs typeface="楷体" charset="0"/>
+              </a:rPr>
+              <a:t/>
+            </a:r>
+            <a:r>
+              <a:rPr lang="zh-CN" altLang="en-US" sz="3000" b="1" spc="100" dirty="0">
+                <a:solidFill>
+                  <a:schemeClr val="bg1"/>
+                </a:solidFill>
+                <a:latin typeface="楷体" charset="0"/>
+                <a:ea typeface="楷体" charset="0"/>
+                <a:cs typeface="楷体" charset="0"/>
+              </a:rPr>
+              <a:t/>
+            </a:r>
             <a:endParaRPr lang="zh-CN" altLang="en-US" sz="3000" b="1" spc="100" dirty="0">
               <a:solidFill>
                 <a:schemeClr val="bg1"/>
@@ -12187,6 +12555,30 @@
                 <a:sym typeface="+mn-ea"/>
               </a:rPr>
               <a:t>1. 多轮对话式写作答疑，支持连续追问</a:t>
+            </a:r>
+            <a:r>
+              <a:rPr lang="en-US" altLang="zh-CN" sz="2000" spc="100" dirty="0">
+                <a:solidFill>
+                  <a:schemeClr val="tx1"/>
+                </a:solidFill>
+                <a:latin typeface="楷体" charset="0"/>
+                <a:ea typeface="楷体" charset="0"/>
+                <a:cs typeface="楷体" charset="0"/>
+                <a:sym typeface="+mn-ea"/>
+              </a:rPr>
+              <a:t/>
+            </a:r>
+            <a:r>
+              <a:rPr lang="zh-CN" altLang="en-US" sz="2000" spc="100" dirty="0">
+                <a:solidFill>
+                  <a:schemeClr val="tx1"/>
+                </a:solidFill>
+                <a:latin typeface="楷体" charset="0"/>
+                <a:ea typeface="楷体" charset="0"/>
+                <a:cs typeface="楷体" charset="0"/>
+                <a:sym typeface="+mn-ea"/>
+              </a:rPr>
+              <a:t/>
             </a:r>
             <a:endParaRPr lang="zh-CN" altLang="en-US" sz="2000" spc="100" dirty="0">
               <a:solidFill>
@@ -12911,7 +13303,67 @@
                 <a:cs typeface="楷体" charset="0"/>
                 <a:sym typeface="+mn-ea"/>
               </a:rPr>
-              <a:t>应用场景概述 | 多设备兼容：电脑/手机/教室白板均可</a:t>
+              <a:t>应用场景概述 | 多设备兼容</a:t>
+            </a:r>
+            <a:r>
+              <a:rPr lang="en-US" altLang="zh-CN" sz="2600" b="1" spc="100" dirty="0">
+                <a:solidFill>
+                  <a:srgbClr val="0070C0"/>
+                </a:solidFill>
+                <a:latin typeface="楷体" charset="0"/>
+                <a:ea typeface="楷体" charset="0"/>
+                <a:cs typeface="楷体" charset="0"/>
+                <a:sym typeface="+mn-ea"/>
+              </a:rPr>
+              <a:t/>
+            </a:r>
+            <a:r>
+              <a:rPr lang="zh-CN" altLang="en-US" sz="2600" b="1" spc="100" dirty="0">
+                <a:solidFill>
+                  <a:srgbClr val="0070C0"/>
+                </a:solidFill>
+                <a:latin typeface="楷体" charset="0"/>
+                <a:ea typeface="楷体" charset="0"/>
+                <a:cs typeface="楷体" charset="0"/>
+                <a:sym typeface="+mn-ea"/>
+              </a:rPr>
+              <a:t/>
+            </a:r>
+            <a:r>
+              <a:rPr lang="en-US" altLang="zh-CN" sz="2600" b="1" spc="100" dirty="0">
+                <a:solidFill>
+                  <a:srgbClr val="0070C0"/>
+                </a:solidFill>
+                <a:latin typeface="楷体" charset="0"/>
+                <a:ea typeface="楷体" charset="0"/>
+                <a:cs typeface="楷体" charset="0"/>
+                <a:sym typeface="+mn-ea"/>
+              </a:rPr>
+              <a:t/>
+            </a:r>
+            <a:r>
+              <a:rPr lang="zh-CN" altLang="en-US" sz="2600" b="1" spc="100" dirty="0">
+                <a:solidFill>
+                  <a:srgbClr val="0070C0"/>
+                </a:solidFill>
+                <a:latin typeface="楷体" charset="0"/>
+                <a:ea typeface="楷体" charset="0"/>
+                <a:cs typeface="楷体" charset="0"/>
+                <a:sym typeface="+mn-ea"/>
+              </a:rPr>
+              <a:t/>
+            </a:r>
+            <a:r>
+              <a:rPr lang="en-US" altLang="zh-CN" sz="2600" b="1" spc="100" dirty="0">
+                <a:solidFill>
+                  <a:srgbClr val="0070C0"/>
+                </a:solidFill>
+                <a:latin typeface="楷体" charset="0"/>
+                <a:ea typeface="楷体" charset="0"/>
+                <a:cs typeface="楷体" charset="0"/>
+                <a:sym typeface="+mn-ea"/>
+              </a:rPr>
+              <a:t/>
             </a:r>
             <a:endParaRPr lang="en-US" altLang="zh-CN" sz="2600" b="1" spc="100" dirty="0">
               <a:solidFill>
@@ -13078,6 +13530,54 @@
               </a:rPr>
               <a:t>习作指导课 + 课后批改 + 自主练习</a:t>
             </a:r>
+            <a:r>
+              <a:rPr lang="en-US" altLang="zh-CN" sz="2600" b="1" spc="100" dirty="0">
+                <a:solidFill>
+                  <a:srgbClr val="0070C0"/>
+                </a:solidFill>
+                <a:latin typeface="楷体" charset="0"/>
+                <a:ea typeface="楷体" charset="0"/>
+                <a:cs typeface="楷体" charset="0"/>
+                <a:sym typeface="+mn-ea"/>
+              </a:rPr>
+              <a:t/>
+            </a:r>
+            <a:r>
+              <a:rPr lang="zh-CN" altLang="en-US" sz="2600" b="1" spc="100" dirty="0">
+                <a:solidFill>
+                  <a:srgbClr val="0070C0"/>
+                </a:solidFill>
+                <a:latin typeface="楷体" charset="0"/>
+                <a:ea typeface="楷体" charset="0"/>
+                <a:cs typeface="楷体" charset="0"/>
+                <a:sym typeface="+mn-ea"/>
+              </a:rPr>
+              <a:t/>
+            </a:r>
+            <a:r>
+              <a:rPr lang="zh-CN" sz="2600" b="1" spc="100" dirty="0">
+                <a:solidFill>
+                  <a:srgbClr val="0070C0"/>
+                </a:solidFill>
+                <a:latin typeface="楷体" charset="0"/>
+                <a:ea typeface="楷体" charset="0"/>
+                <a:cs typeface="楷体" charset="0"/>
+                <a:sym typeface="+mn-ea"/>
+              </a:rPr>
+              <a:t/>
+            </a:r>
+            <a:r>
+              <a:rPr lang="en-US" altLang="zh-CN" sz="2600" b="1" spc="100" dirty="0">
+                <a:solidFill>
+                  <a:srgbClr val="0070C0"/>
+                </a:solidFill>
+                <a:latin typeface="楷体" charset="0"/>
+                <a:ea typeface="楷体" charset="0"/>
+                <a:cs typeface="楷体" charset="0"/>
+                <a:sym typeface="+mn-ea"/>
+              </a:rPr>
+              <a:t/>
+            </a:r>
             <a:endParaRPr lang="en-US" altLang="zh-CN" sz="2600" b="1" spc="100" dirty="0">
               <a:solidFill>
                 <a:srgbClr val="0070C0"/>
@@ -13453,6 +13953,18 @@
               <a:buSzTx/>
               <a:buFontTx/>
             </a:pPr>
+            <a:r>
+              <a:rPr lang="zh-CN" altLang="en-US" sz="2600" b="1" spc="100" dirty="0">
+                <a:solidFill>
+                  <a:srgbClr val="0070C0"/>
+                </a:solidFill>
+                <a:latin typeface="楷体" charset="0"/>
+                <a:ea typeface="楷体" charset="0"/>
+                <a:cs typeface="楷体" charset="0"/>
+                <a:sym typeface="+mn-ea"/>
+              </a:rPr>
+              <a:t/>
+            </a:r>
             <a:endParaRPr lang="zh-CN" altLang="en-US" sz="2600" b="1" spc="100" dirty="0">
               <a:solidFill>
                 <a:srgbClr val="0070C0"/>
@@ -15297,6 +15809,42 @@
               </a:rPr>
               <a:t>一、课堂应用</a:t>
             </a:r>
+            <a:r>
+              <a:rPr lang="zh-CN" sz="3000" b="1" spc="100" dirty="0">
+                <a:solidFill>
+                  <a:schemeClr val="bg1"/>
+                </a:solidFill>
+                <a:latin typeface="楷体" charset="0"/>
+                <a:ea typeface="楷体" charset="0"/>
+                <a:cs typeface="楷体" charset="0"/>
+                <a:sym typeface="+mn-ea"/>
+              </a:rPr>
+              <a:t/>
+            </a:r>
+            <a:r>
+              <a:rPr lang="en-US" altLang="zh-CN" sz="3000" b="1" spc="100" dirty="0">
+                <a:solidFill>
+                  <a:schemeClr val="bg1"/>
+                </a:solidFill>
+                <a:latin typeface="楷体" charset="0"/>
+                <a:ea typeface="楷体" charset="0"/>
+                <a:cs typeface="楷体" charset="0"/>
+                <a:sym typeface="+mn-ea"/>
+              </a:rPr>
+              <a:t/>
+            </a:r>
+            <a:r>
+              <a:rPr lang="zh-CN" altLang="en-US" sz="3000" b="1" spc="100" dirty="0">
+                <a:solidFill>
+                  <a:schemeClr val="bg1"/>
+                </a:solidFill>
+                <a:latin typeface="楷体" charset="0"/>
+                <a:ea typeface="楷体" charset="0"/>
+                <a:cs typeface="楷体" charset="0"/>
+                <a:sym typeface="+mn-ea"/>
+              </a:rPr>
+              <a:t/>
+            </a:r>
             <a:endParaRPr lang="zh-CN" altLang="en-US" sz="3000" b="1" spc="100" dirty="0">
               <a:solidFill>
                 <a:schemeClr val="bg1"/>
@@ -15752,6 +16300,30 @@
                 <a:sym typeface="+mn-ea"/>
               </a:rPr>
               <a:t>1. 习作指导课：AI一对一辅导，每个学生都有针对性建议</a:t>
+            </a:r>
+            <a:r>
+              <a:rPr lang="en-US" altLang="zh-CN" sz="2000" spc="100" dirty="0">
+                <a:solidFill>
+                  <a:schemeClr val="tx1"/>
+                </a:solidFill>
+                <a:latin typeface="楷体" charset="0"/>
+                <a:ea typeface="楷体" charset="0"/>
+                <a:cs typeface="楷体" charset="0"/>
+                <a:sym typeface="+mn-ea"/>
+              </a:rPr>
+              <a:t/>
+            </a:r>
+            <a:r>
+              <a:rPr lang="zh-CN" altLang="en-US" sz="2000" spc="100" dirty="0">
+                <a:solidFill>
+                  <a:schemeClr val="tx1"/>
+                </a:solidFill>
+                <a:latin typeface="楷体" charset="0"/>
+                <a:ea typeface="楷体" charset="0"/>
+                <a:cs typeface="楷体" charset="0"/>
+                <a:sym typeface="+mn-ea"/>
+              </a:rPr>
+              <a:t/>
             </a:r>
             <a:endParaRPr lang="zh-CN" altLang="en-US" sz="2000" spc="100" dirty="0">
               <a:solidFill>
@@ -15963,6 +16535,39 @@
               </a:rPr>
               <a:t>二、创新与合规</a:t>
             </a:r>
+            <a:r>
+              <a:rPr lang="zh-CN" sz="3000" b="1" spc="100" dirty="0">
+                <a:solidFill>
+                  <a:schemeClr val="bg1"/>
+                </a:solidFill>
+                <a:latin typeface="楷体" charset="0"/>
+                <a:ea typeface="楷体" charset="0"/>
+                <a:cs typeface="楷体" charset="0"/>
+              </a:rPr>
+              <a:t/>
+            </a:r>
+            <a:r>
+              <a:rPr lang="en-US" altLang="zh-CN" sz="3000" b="1" spc="100" dirty="0">
+                <a:solidFill>
+                  <a:schemeClr val="bg1"/>
+                </a:solidFill>
+                <a:latin typeface="楷体" charset="0"/>
+                <a:ea typeface="楷体" charset="0"/>
+                <a:cs typeface="楷体" charset="0"/>
+              </a:rPr>
+              <a:t/>
+            </a:r>
+            <a:r>
+              <a:rPr lang="zh-CN" altLang="en-US" sz="3000" b="1" spc="100" dirty="0">
+                <a:solidFill>
+                  <a:schemeClr val="bg1"/>
+                </a:solidFill>
+                <a:latin typeface="楷体" charset="0"/>
+                <a:ea typeface="楷体" charset="0"/>
+                <a:cs typeface="楷体" charset="0"/>
+              </a:rPr>
+              <a:t/>
+            </a:r>
             <a:endParaRPr lang="zh-CN" altLang="en-US" sz="3000" b="1" spc="100" dirty="0">
               <a:solidFill>
                 <a:schemeClr val="bg1"/>
@@ -16265,6 +16870,30 @@
                 <a:sym typeface="+mn-ea"/>
               </a:rPr>
               <a:t>1. 一生一导个性化教学 + 精准聚焦高频痛点 + 严格遵循AI使用指南</a:t>
+            </a:r>
+            <a:r>
+              <a:rPr lang="en-US" altLang="zh-CN" sz="2000" spc="100" dirty="0">
+                <a:solidFill>
+                  <a:schemeClr val="tx1"/>
+                </a:solidFill>
+                <a:latin typeface="楷体" charset="0"/>
+                <a:ea typeface="楷体" charset="0"/>
+                <a:cs typeface="楷体" charset="0"/>
+                <a:sym typeface="+mn-ea"/>
+              </a:rPr>
+              <a:t/>
+            </a:r>
+            <a:r>
+              <a:rPr lang="zh-CN" altLang="en-US" sz="2000" spc="100" dirty="0">
+                <a:solidFill>
+                  <a:schemeClr val="tx1"/>
+                </a:solidFill>
+                <a:latin typeface="楷体" charset="0"/>
+                <a:ea typeface="楷体" charset="0"/>
+                <a:cs typeface="楷体" charset="0"/>
+                <a:sym typeface="+mn-ea"/>
+              </a:rPr>
+              <a:t/>
             </a:r>
             <a:endParaRPr lang="zh-CN" altLang="en-US" sz="2000" spc="100" dirty="0">
               <a:solidFill>
@@ -16534,7 +17163,6 @@
               <a:rPr sz="1200"/>
               <a:t>GitHub: github.com/707978439-cpu/animal-writing-assistant</a:t>
             </a:r>
-            <a:endParaRPr sz="1200"/>
           </a:p>
         </p:txBody>
       </p:sp>

</xml_diff>